<commit_message>
Section6c (Adoption, 2 slides) + Section7 (Close, 5 slides) PPTX: hand-tuned to HTML — numbered reframe cards; Lesion/Image/Patient recap, discipline-in-three-lines, the-image-hasn't-changed turn, thank-you. Gradient bg. Completes all 8 sections.
</commit_message>
<xml_diff>
--- a/keynote-iwbi-2026/pptx/sections/IWBI2026_Trivedi_06c_adoption.pptx
+++ b/keynote-iwbi-2026/pptx/sections/IWBI2026_Trivedi_06c_adoption.pptx
@@ -3587,16 +3587,40 @@
         <p:nvPr/>
       </p:nvGrpSpPr>
       <p:grpSpPr/>
-      <p:sp>
-        <p:nvSpPr>
-          <p:cNvPr id="2" name="Rectangle 1"/>
-          <p:cNvSpPr/>
+      <p:pic>
+        <p:nvPicPr>
+          <p:cNvPr id="2" name="Picture 1" descr="bg_motif.png"/>
+          <p:cNvPicPr>
+            <a:picLocks noChangeAspect="1"/>
+          </p:cNvPicPr>
           <p:nvPr/>
-        </p:nvSpPr>
+        </p:nvPicPr>
+        <p:blipFill>
+          <a:blip r:embed="rId2"/>
+          <a:stretch>
+            <a:fillRect/>
+          </a:stretch>
+        </p:blipFill>
         <p:spPr>
           <a:xfrm>
             <a:off x="0" y="0"/>
-            <a:ext cx="12191695" cy="38100"/>
+            <a:ext cx="12191695" cy="6858000"/>
+          </a:xfrm>
+          <a:prstGeom prst="rect">
+            <a:avLst/>
+          </a:prstGeom>
+        </p:spPr>
+      </p:pic>
+      <p:sp>
+        <p:nvSpPr>
+          <p:cNvPr id="3" name="Rectangle 2"/>
+          <p:cNvSpPr/>
+          <p:nvPr/>
+        </p:nvSpPr>
+        <p:spPr>
+          <a:xfrm>
+            <a:off x="0" y="0"/>
+            <a:ext cx="5486400" cy="38100"/>
           </a:xfrm>
           <a:prstGeom prst="rect">
             <a:avLst/>
@@ -3633,14 +3657,14 @@
       </p:sp>
       <p:sp>
         <p:nvSpPr>
-          <p:cNvPr id="3" name="TextBox 2"/>
+          <p:cNvPr id="4" name="TextBox 3"/>
           <p:cNvSpPr txBox="1"/>
           <p:nvPr/>
         </p:nvSpPr>
         <p:spPr>
           <a:xfrm>
-            <a:off x="777240" y="411480"/>
-            <a:ext cx="8686800" cy="365760"/>
+            <a:off x="777240" y="502920"/>
+            <a:ext cx="8229600" cy="320040"/>
           </a:xfrm>
           <a:prstGeom prst="rect">
             <a:avLst/>
@@ -3648,21 +3672,18 @@
           <a:noFill/>
         </p:spPr>
         <p:txBody>
-          <a:bodyPr wrap="square" lIns="25400" rIns="25400" tIns="12700" bIns="12700">
-            <a:noAutofit/>
+          <a:bodyPr wrap="square" anchor="t" lIns="0" rIns="0" tIns="0" bIns="0">
+            <a:spAutoFit/>
           </a:bodyPr>
           <a:lstStyle/>
           <a:p>
             <a:pPr algn="l">
               <a:lnSpc>
-                <a:spcPct val="128000"/>
+                <a:spcPct val="100000"/>
               </a:lnSpc>
-              <a:spcAft>
-                <a:spcPts val="400"/>
-              </a:spcAft>
             </a:pPr>
             <a:r>
-              <a:rPr sz="1100" b="1">
+              <a:rPr sz="1100" b="1" i="0">
                 <a:solidFill>
                   <a:srgbClr val="E7AC51"/>
                 </a:solidFill>
@@ -3675,14 +3696,14 @@
       </p:sp>
       <p:sp>
         <p:nvSpPr>
-          <p:cNvPr id="4" name="TextBox 3"/>
+          <p:cNvPr id="5" name="TextBox 4"/>
           <p:cNvSpPr txBox="1"/>
           <p:nvPr/>
         </p:nvSpPr>
         <p:spPr>
           <a:xfrm>
-            <a:off x="777240" y="2569971"/>
-            <a:ext cx="10607040" cy="534416"/>
+            <a:off x="777240" y="960120"/>
+            <a:ext cx="10424160" cy="914400"/>
           </a:xfrm>
           <a:prstGeom prst="rect">
             <a:avLst/>
@@ -3690,21 +3711,18 @@
           <a:noFill/>
         </p:spPr>
         <p:txBody>
-          <a:bodyPr wrap="square" lIns="25400" rIns="25400" tIns="12700" bIns="12700">
-            <a:noAutofit/>
+          <a:bodyPr wrap="square" anchor="t" lIns="0" rIns="0" tIns="0" bIns="0">
+            <a:spAutoFit/>
           </a:bodyPr>
           <a:lstStyle/>
           <a:p>
             <a:pPr algn="l">
               <a:lnSpc>
-                <a:spcPct val="106000"/>
+                <a:spcPct val="110000"/>
               </a:lnSpc>
-              <a:spcAft>
-                <a:spcPts val="400"/>
-              </a:spcAft>
             </a:pPr>
             <a:r>
-              <a:rPr sz="2600" b="0">
+              <a:rPr sz="2700" b="1" i="0">
                 <a:solidFill>
                   <a:srgbClr val="ECEFF3"/>
                 </a:solidFill>
@@ -3713,7 +3731,7 @@
               <a:t>One model for everything is </a:t>
             </a:r>
             <a:r>
-              <a:rPr sz="2600" b="0">
+              <a:rPr sz="2700" b="1" i="0">
                 <a:solidFill>
                   <a:srgbClr val="E7AC51"/>
                 </a:solidFill>
@@ -3726,14 +3744,14 @@
       </p:sp>
       <p:sp>
         <p:nvSpPr>
-          <p:cNvPr id="5" name="TextBox 4"/>
+          <p:cNvPr id="6" name="TextBox 5"/>
           <p:cNvSpPr txBox="1"/>
           <p:nvPr/>
         </p:nvSpPr>
         <p:spPr>
           <a:xfrm>
-            <a:off x="777240" y="3104387"/>
-            <a:ext cx="10607040" cy="346456"/>
+            <a:off x="777240" y="2011680"/>
+            <a:ext cx="10424160" cy="548640"/>
           </a:xfrm>
           <a:prstGeom prst="rect">
             <a:avLst/>
@@ -3741,21 +3759,18 @@
           <a:noFill/>
         </p:spPr>
         <p:txBody>
-          <a:bodyPr wrap="square" lIns="25400" rIns="25400" tIns="12700" bIns="12700">
-            <a:noAutofit/>
+          <a:bodyPr wrap="square" anchor="t" lIns="0" rIns="0" tIns="0" bIns="0">
+            <a:spAutoFit/>
           </a:bodyPr>
           <a:lstStyle/>
           <a:p>
             <a:pPr algn="l">
               <a:lnSpc>
-                <a:spcPct val="128000"/>
+                <a:spcPct val="135000"/>
               </a:lnSpc>
-              <a:spcAft>
-                <a:spcPts val="400"/>
-              </a:spcAft>
             </a:pPr>
             <a:r>
-              <a:rPr sz="1400" b="0">
+              <a:rPr sz="1500" b="0" i="0">
                 <a:solidFill>
                   <a:srgbClr val="9DA9B5"/>
                 </a:solidFill>
@@ -3764,7 +3779,7 @@
               <a:t>We chased better detection for three decades. But look at what we ask a </a:t>
             </a:r>
             <a:r>
-              <a:rPr sz="1400" b="1">
+              <a:rPr sz="1500" b="1" i="0">
                 <a:solidFill>
                   <a:srgbClr val="ECEFF3"/>
                 </a:solidFill>
@@ -3773,7 +3788,7 @@
               <a:t>single</a:t>
             </a:r>
             <a:r>
-              <a:rPr sz="1400" b="0">
+              <a:rPr sz="1500" b="0" i="0">
                 <a:solidFill>
                   <a:srgbClr val="9DA9B5"/>
                 </a:solidFill>
@@ -3786,14 +3801,14 @@
       </p:sp>
       <p:sp>
         <p:nvSpPr>
-          <p:cNvPr id="6" name="TextBox 5"/>
+          <p:cNvPr id="7" name="TextBox 6"/>
           <p:cNvSpPr txBox="1"/>
           <p:nvPr/>
         </p:nvSpPr>
         <p:spPr>
           <a:xfrm>
-            <a:off x="777240" y="3450843"/>
-            <a:ext cx="10607040" cy="346456"/>
+            <a:off x="777240" y="2788920"/>
+            <a:ext cx="457200" cy="548640"/>
           </a:xfrm>
           <a:prstGeom prst="rect">
             <a:avLst/>
@@ -3801,68 +3816,38 @@
           <a:noFill/>
         </p:spPr>
         <p:txBody>
-          <a:bodyPr wrap="square" lIns="25400" rIns="25400" tIns="12700" bIns="12700">
-            <a:noAutofit/>
+          <a:bodyPr wrap="square" anchor="t" lIns="0" rIns="0" tIns="0" bIns="0">
+            <a:spAutoFit/>
           </a:bodyPr>
           <a:lstStyle/>
           <a:p>
             <a:pPr algn="l">
               <a:lnSpc>
-                <a:spcPct val="128000"/>
+                <a:spcPct val="100000"/>
               </a:lnSpc>
-              <a:spcAft>
-                <a:spcPts val="400"/>
-              </a:spcAft>
             </a:pPr>
             <a:r>
-              <a:rPr sz="1400" b="0">
-                <a:solidFill>
-                  <a:srgbClr val="9DA9B5"/>
-                </a:solidFill>
-                <a:latin typeface="Arial"/>
+              <a:rPr sz="1500" b="1" i="0">
+                <a:solidFill>
+                  <a:srgbClr val="E7AC51"/>
+                </a:solidFill>
+                <a:latin typeface="Consolas"/>
               </a:rPr>
               <a:t>01</a:t>
             </a:r>
-            <a:r>
-              <a:rPr sz="1400" b="0">
-                <a:solidFill>
-                  <a:srgbClr val="9DA9B5"/>
-                </a:solidFill>
-                <a:latin typeface="Arial"/>
-              </a:rPr>
-              <a:t>Hold up across </a:t>
-            </a:r>
-            <a:r>
-              <a:rPr sz="1400" b="1">
-                <a:solidFill>
-                  <a:srgbClr val="ECEFF3"/>
-                </a:solidFill>
-                <a:latin typeface="Arial"/>
-              </a:rPr>
-              <a:t>every scanner and vendor</a:t>
-            </a:r>
-            <a:r>
-              <a:rPr sz="1400" b="0">
-                <a:solidFill>
-                  <a:srgbClr val="9DA9B5"/>
-                </a:solidFill>
-                <a:latin typeface="Arial"/>
-              </a:rPr>
-              <a:t> in the field</a:t>
-            </a:r>
-          </a:p>
-        </p:txBody>
-      </p:sp>
-      <p:sp>
-        <p:nvSpPr>
-          <p:cNvPr id="7" name="TextBox 6"/>
+          </a:p>
+        </p:txBody>
+      </p:sp>
+      <p:sp>
+        <p:nvSpPr>
+          <p:cNvPr id="8" name="TextBox 7"/>
           <p:cNvSpPr txBox="1"/>
           <p:nvPr/>
         </p:nvSpPr>
         <p:spPr>
           <a:xfrm>
-            <a:off x="777240" y="3797300"/>
-            <a:ext cx="10607040" cy="346456"/>
+            <a:off x="1280160" y="2788920"/>
+            <a:ext cx="9921240" cy="548640"/>
           </a:xfrm>
           <a:prstGeom prst="rect">
             <a:avLst/>
@@ -3870,59 +3855,56 @@
           <a:noFill/>
         </p:spPr>
         <p:txBody>
-          <a:bodyPr wrap="square" lIns="25400" rIns="25400" tIns="12700" bIns="12700">
-            <a:noAutofit/>
+          <a:bodyPr wrap="square" anchor="t" lIns="0" rIns="0" tIns="0" bIns="0">
+            <a:spAutoFit/>
           </a:bodyPr>
           <a:lstStyle/>
           <a:p>
             <a:pPr algn="l">
               <a:lnSpc>
-                <a:spcPct val="128000"/>
+                <a:spcPct val="134000"/>
               </a:lnSpc>
-              <a:spcAft>
-                <a:spcPts val="400"/>
-              </a:spcAft>
             </a:pPr>
             <a:r>
-              <a:rPr sz="1400" b="0">
-                <a:solidFill>
-                  <a:srgbClr val="9DA9B5"/>
+              <a:rPr sz="1500" b="1" i="0">
+                <a:solidFill>
+                  <a:srgbClr val="ECEFF3"/>
                 </a:solidFill>
                 <a:latin typeface="Arial"/>
               </a:rPr>
-              <a:t>02</a:t>
-            </a:r>
-            <a:r>
-              <a:rPr sz="1400" b="0">
-                <a:solidFill>
-                  <a:srgbClr val="9DA9B5"/>
+              <a:t>Hold up across  </a:t>
+            </a:r>
+            <a:r>
+              <a:rPr sz="1350" b="1" i="0">
+                <a:solidFill>
+                  <a:srgbClr val="ECEFF3"/>
                 </a:solidFill>
                 <a:latin typeface="Arial"/>
               </a:rPr>
-              <a:t>Perform in women of </a:t>
-            </a:r>
-            <a:r>
-              <a:rPr sz="1400" b="1">
-                <a:solidFill>
-                  <a:srgbClr val="ECEFF3"/>
+              <a:t>every scanner and vendor</a:t>
+            </a:r>
+            <a:r>
+              <a:rPr sz="1350" b="0" i="0">
+                <a:solidFill>
+                  <a:srgbClr val="9DA9B5"/>
                 </a:solidFill>
                 <a:latin typeface="Arial"/>
               </a:rPr>
-              <a:t>all ages, all densities, all risk types</a:t>
-            </a:r>
-          </a:p>
-        </p:txBody>
-      </p:sp>
-      <p:sp>
-        <p:nvSpPr>
-          <p:cNvPr id="8" name="TextBox 7"/>
+              <a:t> in the field</a:t>
+            </a:r>
+          </a:p>
+        </p:txBody>
+      </p:sp>
+      <p:sp>
+        <p:nvSpPr>
+          <p:cNvPr id="9" name="TextBox 8"/>
           <p:cNvSpPr txBox="1"/>
           <p:nvPr/>
         </p:nvSpPr>
         <p:spPr>
           <a:xfrm>
-            <a:off x="777240" y="4143755"/>
-            <a:ext cx="10607040" cy="346456"/>
+            <a:off x="777240" y="3429000"/>
+            <a:ext cx="457200" cy="548640"/>
           </a:xfrm>
           <a:prstGeom prst="rect">
             <a:avLst/>
@@ -3930,77 +3912,38 @@
           <a:noFill/>
         </p:spPr>
         <p:txBody>
-          <a:bodyPr wrap="square" lIns="25400" rIns="25400" tIns="12700" bIns="12700">
-            <a:noAutofit/>
+          <a:bodyPr wrap="square" anchor="t" lIns="0" rIns="0" tIns="0" bIns="0">
+            <a:spAutoFit/>
           </a:bodyPr>
           <a:lstStyle/>
           <a:p>
             <a:pPr algn="l">
               <a:lnSpc>
-                <a:spcPct val="128000"/>
+                <a:spcPct val="100000"/>
               </a:lnSpc>
-              <a:spcAft>
-                <a:spcPts val="400"/>
-              </a:spcAft>
             </a:pPr>
             <a:r>
-              <a:rPr sz="1400" b="0">
-                <a:solidFill>
-                  <a:srgbClr val="9DA9B5"/>
-                </a:solidFill>
-                <a:latin typeface="Arial"/>
+              <a:rPr sz="1500" b="1" i="0">
+                <a:solidFill>
+                  <a:srgbClr val="E7AC51"/>
+                </a:solidFill>
+                <a:latin typeface="Consolas"/>
               </a:rPr>
-              <a:t>03</a:t>
-            </a:r>
-            <a:r>
-              <a:rPr sz="1400" b="0">
-                <a:solidFill>
-                  <a:srgbClr val="9DA9B5"/>
-                </a:solidFill>
-                <a:latin typeface="Arial"/>
-              </a:rPr>
-              <a:t>Serve both the </a:t>
-            </a:r>
-            <a:r>
-              <a:rPr sz="1400" b="1">
-                <a:solidFill>
-                  <a:srgbClr val="ECEFF3"/>
-                </a:solidFill>
-                <a:latin typeface="Arial"/>
-              </a:rPr>
-              <a:t>expert breast radiologist</a:t>
-            </a:r>
-            <a:r>
-              <a:rPr sz="1400" b="0">
-                <a:solidFill>
-                  <a:srgbClr val="9DA9B5"/>
-                </a:solidFill>
-                <a:latin typeface="Arial"/>
-              </a:rPr>
-              <a:t> and the </a:t>
-            </a:r>
-            <a:r>
-              <a:rPr sz="1400" b="1">
-                <a:solidFill>
-                  <a:srgbClr val="ECEFF3"/>
-                </a:solidFill>
-                <a:latin typeface="Arial"/>
-              </a:rPr>
-              <a:t>generalist who reads mammo one day a week</a:t>
-            </a:r>
-          </a:p>
-        </p:txBody>
-      </p:sp>
-      <p:sp>
-        <p:nvSpPr>
-          <p:cNvPr id="9" name="TextBox 8"/>
+              <a:t>02</a:t>
+            </a:r>
+          </a:p>
+        </p:txBody>
+      </p:sp>
+      <p:sp>
+        <p:nvSpPr>
+          <p:cNvPr id="10" name="TextBox 9"/>
           <p:cNvSpPr txBox="1"/>
           <p:nvPr/>
         </p:nvSpPr>
         <p:spPr>
           <a:xfrm>
-            <a:off x="777240" y="4490211"/>
-            <a:ext cx="10607040" cy="346456"/>
+            <a:off x="1280160" y="3429000"/>
+            <a:ext cx="9921240" cy="548640"/>
           </a:xfrm>
           <a:prstGeom prst="rect">
             <a:avLst/>
@@ -4008,21 +3951,171 @@
           <a:noFill/>
         </p:spPr>
         <p:txBody>
-          <a:bodyPr wrap="square" lIns="25400" rIns="25400" tIns="12700" bIns="12700">
-            <a:noAutofit/>
+          <a:bodyPr wrap="square" anchor="t" lIns="0" rIns="0" tIns="0" bIns="0">
+            <a:spAutoFit/>
           </a:bodyPr>
           <a:lstStyle/>
           <a:p>
             <a:pPr algn="l">
               <a:lnSpc>
-                <a:spcPct val="128000"/>
+                <a:spcPct val="134000"/>
               </a:lnSpc>
-              <a:spcAft>
-                <a:spcPts val="400"/>
-              </a:spcAft>
             </a:pPr>
             <a:r>
-              <a:rPr sz="1400" b="0">
+              <a:rPr sz="1500" b="1" i="0">
+                <a:solidFill>
+                  <a:srgbClr val="ECEFF3"/>
+                </a:solidFill>
+                <a:latin typeface="Arial"/>
+              </a:rPr>
+              <a:t>Perform in women of  </a:t>
+            </a:r>
+            <a:r>
+              <a:rPr sz="1350" b="1" i="0">
+                <a:solidFill>
+                  <a:srgbClr val="ECEFF3"/>
+                </a:solidFill>
+                <a:latin typeface="Arial"/>
+              </a:rPr>
+              <a:t>all ages, all densities, all risk types</a:t>
+            </a:r>
+          </a:p>
+        </p:txBody>
+      </p:sp>
+      <p:sp>
+        <p:nvSpPr>
+          <p:cNvPr id="11" name="TextBox 10"/>
+          <p:cNvSpPr txBox="1"/>
+          <p:nvPr/>
+        </p:nvSpPr>
+        <p:spPr>
+          <a:xfrm>
+            <a:off x="777240" y="4069080"/>
+            <a:ext cx="457200" cy="731520"/>
+          </a:xfrm>
+          <a:prstGeom prst="rect">
+            <a:avLst/>
+          </a:prstGeom>
+          <a:noFill/>
+        </p:spPr>
+        <p:txBody>
+          <a:bodyPr wrap="square" anchor="t" lIns="0" rIns="0" tIns="0" bIns="0">
+            <a:spAutoFit/>
+          </a:bodyPr>
+          <a:lstStyle/>
+          <a:p>
+            <a:pPr algn="l">
+              <a:lnSpc>
+                <a:spcPct val="100000"/>
+              </a:lnSpc>
+            </a:pPr>
+            <a:r>
+              <a:rPr sz="1500" b="1" i="0">
+                <a:solidFill>
+                  <a:srgbClr val="E7AC51"/>
+                </a:solidFill>
+                <a:latin typeface="Consolas"/>
+              </a:rPr>
+              <a:t>03</a:t>
+            </a:r>
+          </a:p>
+        </p:txBody>
+      </p:sp>
+      <p:sp>
+        <p:nvSpPr>
+          <p:cNvPr id="12" name="TextBox 11"/>
+          <p:cNvSpPr txBox="1"/>
+          <p:nvPr/>
+        </p:nvSpPr>
+        <p:spPr>
+          <a:xfrm>
+            <a:off x="1280160" y="4069080"/>
+            <a:ext cx="9921240" cy="731520"/>
+          </a:xfrm>
+          <a:prstGeom prst="rect">
+            <a:avLst/>
+          </a:prstGeom>
+          <a:noFill/>
+        </p:spPr>
+        <p:txBody>
+          <a:bodyPr wrap="square" anchor="t" lIns="0" rIns="0" tIns="0" bIns="0">
+            <a:spAutoFit/>
+          </a:bodyPr>
+          <a:lstStyle/>
+          <a:p>
+            <a:pPr algn="l">
+              <a:lnSpc>
+                <a:spcPct val="134000"/>
+              </a:lnSpc>
+            </a:pPr>
+            <a:r>
+              <a:rPr sz="1500" b="1" i="0">
+                <a:solidFill>
+                  <a:srgbClr val="ECEFF3"/>
+                </a:solidFill>
+                <a:latin typeface="Arial"/>
+              </a:rPr>
+              <a:t>Serve both the  </a:t>
+            </a:r>
+            <a:r>
+              <a:rPr sz="1350" b="1" i="0">
+                <a:solidFill>
+                  <a:srgbClr val="ECEFF3"/>
+                </a:solidFill>
+                <a:latin typeface="Arial"/>
+              </a:rPr>
+              <a:t>expert breast radiologist</a:t>
+            </a:r>
+            <a:r>
+              <a:rPr sz="1350" b="0" i="0">
+                <a:solidFill>
+                  <a:srgbClr val="9DA9B5"/>
+                </a:solidFill>
+                <a:latin typeface="Arial"/>
+              </a:rPr>
+              <a:t> and the </a:t>
+            </a:r>
+            <a:r>
+              <a:rPr sz="1350" b="1" i="0">
+                <a:solidFill>
+                  <a:srgbClr val="ECEFF3"/>
+                </a:solidFill>
+                <a:latin typeface="Arial"/>
+              </a:rPr>
+              <a:t>generalist who reads mammo one day a week</a:t>
+            </a:r>
+          </a:p>
+        </p:txBody>
+      </p:sp>
+      <p:sp>
+        <p:nvSpPr>
+          <p:cNvPr id="13" name="TextBox 12"/>
+          <p:cNvSpPr txBox="1"/>
+          <p:nvPr/>
+        </p:nvSpPr>
+        <p:spPr>
+          <a:xfrm>
+            <a:off x="777240" y="5029200"/>
+            <a:ext cx="10424160" cy="640080"/>
+          </a:xfrm>
+          <a:prstGeom prst="rect">
+            <a:avLst/>
+          </a:prstGeom>
+          <a:noFill/>
+        </p:spPr>
+        <p:txBody>
+          <a:bodyPr wrap="square" anchor="t" lIns="0" rIns="0" tIns="0" bIns="0">
+            <a:spAutoFit/>
+          </a:bodyPr>
+          <a:lstStyle/>
+          <a:p>
+            <a:pPr algn="l">
+              <a:lnSpc>
+                <a:spcPct val="135000"/>
+              </a:lnSpc>
+            </a:pPr>
+            <a:r>
+              <a:rPr sz="1600" b="0" i="0">
                 <a:solidFill>
                   <a:srgbClr val="9DA9B5"/>
                 </a:solidFill>
@@ -4031,9 +4124,9 @@
               <a:t>We should seriously reframe how we consider </a:t>
             </a:r>
             <a:r>
-              <a:rPr sz="1400" b="1">
-                <a:solidFill>
-                  <a:srgbClr val="ECEFF3"/>
+              <a:rPr sz="1600" b="1" i="0">
+                <a:solidFill>
+                  <a:srgbClr val="E7AC51"/>
                 </a:solidFill>
                 <a:latin typeface="Arial"/>
               </a:rPr>
@@ -4068,16 +4161,40 @@
         <p:nvPr/>
       </p:nvGrpSpPr>
       <p:grpSpPr/>
-      <p:sp>
-        <p:nvSpPr>
-          <p:cNvPr id="2" name="Rectangle 1"/>
-          <p:cNvSpPr/>
+      <p:pic>
+        <p:nvPicPr>
+          <p:cNvPr id="2" name="Picture 1" descr="bg_motif.png"/>
+          <p:cNvPicPr>
+            <a:picLocks noChangeAspect="1"/>
+          </p:cNvPicPr>
           <p:nvPr/>
-        </p:nvSpPr>
+        </p:nvPicPr>
+        <p:blipFill>
+          <a:blip r:embed="rId2"/>
+          <a:stretch>
+            <a:fillRect/>
+          </a:stretch>
+        </p:blipFill>
         <p:spPr>
           <a:xfrm>
             <a:off x="0" y="0"/>
-            <a:ext cx="12191695" cy="38100"/>
+            <a:ext cx="12191695" cy="6858000"/>
+          </a:xfrm>
+          <a:prstGeom prst="rect">
+            <a:avLst/>
+          </a:prstGeom>
+        </p:spPr>
+      </p:pic>
+      <p:sp>
+        <p:nvSpPr>
+          <p:cNvPr id="3" name="Rectangle 2"/>
+          <p:cNvSpPr/>
+          <p:nvPr/>
+        </p:nvSpPr>
+        <p:spPr>
+          <a:xfrm>
+            <a:off x="0" y="0"/>
+            <a:ext cx="5486400" cy="38100"/>
           </a:xfrm>
           <a:prstGeom prst="rect">
             <a:avLst/>
@@ -4114,14 +4231,14 @@
       </p:sp>
       <p:sp>
         <p:nvSpPr>
-          <p:cNvPr id="3" name="TextBox 2"/>
+          <p:cNvPr id="4" name="TextBox 3"/>
           <p:cNvSpPr txBox="1"/>
           <p:nvPr/>
         </p:nvSpPr>
         <p:spPr>
           <a:xfrm>
-            <a:off x="777240" y="411480"/>
-            <a:ext cx="8686800" cy="365760"/>
+            <a:off x="777240" y="502920"/>
+            <a:ext cx="8229600" cy="320040"/>
           </a:xfrm>
           <a:prstGeom prst="rect">
             <a:avLst/>
@@ -4129,21 +4246,18 @@
           <a:noFill/>
         </p:spPr>
         <p:txBody>
-          <a:bodyPr wrap="square" lIns="25400" rIns="25400" tIns="12700" bIns="12700">
-            <a:noAutofit/>
+          <a:bodyPr wrap="square" anchor="t" lIns="0" rIns="0" tIns="0" bIns="0">
+            <a:spAutoFit/>
           </a:bodyPr>
           <a:lstStyle/>
           <a:p>
             <a:pPr algn="l">
               <a:lnSpc>
-                <a:spcPct val="128000"/>
+                <a:spcPct val="100000"/>
               </a:lnSpc>
-              <a:spcAft>
-                <a:spcPts val="400"/>
-              </a:spcAft>
             </a:pPr>
             <a:r>
-              <a:rPr sz="1100" b="1">
+              <a:rPr sz="1100" b="1" i="0">
                 <a:solidFill>
                   <a:srgbClr val="E7AC51"/>
                 </a:solidFill>
@@ -4156,14 +4270,14 @@
       </p:sp>
       <p:sp>
         <p:nvSpPr>
-          <p:cNvPr id="4" name="TextBox 3"/>
+          <p:cNvPr id="5" name="TextBox 4"/>
           <p:cNvSpPr txBox="1"/>
           <p:nvPr/>
         </p:nvSpPr>
         <p:spPr>
           <a:xfrm>
-            <a:off x="777240" y="2077211"/>
-            <a:ext cx="10607040" cy="534416"/>
+            <a:off x="777240" y="868680"/>
+            <a:ext cx="10424160" cy="914400"/>
           </a:xfrm>
           <a:prstGeom prst="rect">
             <a:avLst/>
@@ -4171,21 +4285,18 @@
           <a:noFill/>
         </p:spPr>
         <p:txBody>
-          <a:bodyPr wrap="square" lIns="25400" rIns="25400" tIns="12700" bIns="12700">
-            <a:noAutofit/>
+          <a:bodyPr wrap="square" anchor="t" lIns="0" rIns="0" tIns="0" bIns="0">
+            <a:spAutoFit/>
           </a:bodyPr>
           <a:lstStyle/>
           <a:p>
             <a:pPr algn="l">
               <a:lnSpc>
-                <a:spcPct val="106000"/>
+                <a:spcPct val="110000"/>
               </a:lnSpc>
-              <a:spcAft>
-                <a:spcPts val="400"/>
-              </a:spcAft>
             </a:pPr>
             <a:r>
-              <a:rPr sz="2600" b="0">
+              <a:rPr sz="2700" b="1" i="0">
                 <a:solidFill>
                   <a:srgbClr val="ECEFF3"/>
                 </a:solidFill>
@@ -4194,7 +4305,7 @@
               <a:t>How we should deploy </a:t>
             </a:r>
             <a:r>
-              <a:rPr sz="2600" b="0">
+              <a:rPr sz="2700" b="1" i="0">
                 <a:solidFill>
                   <a:srgbClr val="E7AC51"/>
                 </a:solidFill>
@@ -4207,14 +4318,14 @@
       </p:sp>
       <p:sp>
         <p:nvSpPr>
-          <p:cNvPr id="5" name="TextBox 4"/>
+          <p:cNvPr id="6" name="TextBox 5"/>
           <p:cNvSpPr txBox="1"/>
           <p:nvPr/>
         </p:nvSpPr>
         <p:spPr>
           <a:xfrm>
-            <a:off x="777240" y="2611627"/>
-            <a:ext cx="10607040" cy="346456"/>
+            <a:off x="777240" y="1828800"/>
+            <a:ext cx="10424160" cy="365760"/>
           </a:xfrm>
           <a:prstGeom prst="rect">
             <a:avLst/>
@@ -4222,21 +4333,18 @@
           <a:noFill/>
         </p:spPr>
         <p:txBody>
-          <a:bodyPr wrap="square" lIns="25400" rIns="25400" tIns="12700" bIns="12700">
-            <a:noAutofit/>
+          <a:bodyPr wrap="square" anchor="t" lIns="0" rIns="0" tIns="0" bIns="0">
+            <a:spAutoFit/>
           </a:bodyPr>
           <a:lstStyle/>
           <a:p>
             <a:pPr algn="l">
               <a:lnSpc>
-                <a:spcPct val="128000"/>
+                <a:spcPct val="100000"/>
               </a:lnSpc>
-              <a:spcAft>
-                <a:spcPts val="400"/>
-              </a:spcAft>
             </a:pPr>
             <a:r>
-              <a:rPr sz="1400" b="0">
+              <a:rPr sz="1400" b="0" i="0">
                 <a:solidFill>
                   <a:srgbClr val="9DA9B5"/>
                 </a:solidFill>
@@ -4249,14 +4357,14 @@
       </p:sp>
       <p:sp>
         <p:nvSpPr>
-          <p:cNvPr id="6" name="TextBox 5"/>
+          <p:cNvPr id="7" name="TextBox 6"/>
           <p:cNvSpPr txBox="1"/>
           <p:nvPr/>
         </p:nvSpPr>
         <p:spPr>
           <a:xfrm>
-            <a:off x="777240" y="2958084"/>
-            <a:ext cx="10607040" cy="801623"/>
+            <a:off x="777240" y="2423160"/>
+            <a:ext cx="457200" cy="1097280"/>
           </a:xfrm>
           <a:prstGeom prst="rect">
             <a:avLst/>
@@ -4264,95 +4372,38 @@
           <a:noFill/>
         </p:spPr>
         <p:txBody>
-          <a:bodyPr wrap="square" lIns="25400" rIns="25400" tIns="12700" bIns="12700">
-            <a:noAutofit/>
+          <a:bodyPr wrap="square" anchor="t" lIns="0" rIns="0" tIns="0" bIns="0">
+            <a:spAutoFit/>
           </a:bodyPr>
           <a:lstStyle/>
           <a:p>
             <a:pPr algn="l">
               <a:lnSpc>
-                <a:spcPct val="128000"/>
+                <a:spcPct val="100000"/>
               </a:lnSpc>
-              <a:spcAft>
-                <a:spcPts val="400"/>
-              </a:spcAft>
             </a:pPr>
             <a:r>
-              <a:rPr sz="1400" b="0">
-                <a:solidFill>
-                  <a:srgbClr val="9DA9B5"/>
-                </a:solidFill>
-                <a:latin typeface="Arial"/>
+              <a:rPr sz="1500" b="1" i="0">
+                <a:solidFill>
+                  <a:srgbClr val="E7AC51"/>
+                </a:solidFill>
+                <a:latin typeface="Consolas"/>
               </a:rPr>
               <a:t>1</a:t>
             </a:r>
-            <a:r>
-              <a:rPr sz="1400" b="1">
-                <a:solidFill>
-                  <a:srgbClr val="ECEFF3"/>
-                </a:solidFill>
-                <a:latin typeface="Arial"/>
-              </a:rPr>
-              <a:t>Operating points, not one threshold.</a:t>
-            </a:r>
-            <a:r>
-              <a:rPr sz="1400" b="0">
-                <a:solidFill>
-                  <a:srgbClr val="9DA9B5"/>
-                </a:solidFill>
-                <a:latin typeface="Arial"/>
-              </a:rPr>
-              <a:t> Sensitivity vs. false positives is a </a:t>
-            </a:r>
-            <a:r>
-              <a:rPr sz="1400" b="1">
-                <a:solidFill>
-                  <a:srgbClr val="ECEFF3"/>
-                </a:solidFill>
-                <a:latin typeface="Arial"/>
-              </a:rPr>
-              <a:t>value judgment</a:t>
-            </a:r>
-            <a:r>
-              <a:rPr sz="1400" b="0">
-                <a:solidFill>
-                  <a:srgbClr val="9DA9B5"/>
-                </a:solidFill>
-                <a:latin typeface="Arial"/>
-              </a:rPr>
-              <a:t>, not a setting. Let a model run at a range of operating points, </a:t>
-            </a:r>
-            <a:r>
-              <a:rPr sz="1400" b="1">
-                <a:solidFill>
-                  <a:srgbClr val="ECEFF3"/>
-                </a:solidFill>
-                <a:latin typeface="Arial"/>
-              </a:rPr>
-              <a:t>tailored to the site and the radiologist</a:t>
-            </a:r>
-            <a:r>
-              <a:rPr sz="1400" b="0">
-                <a:solidFill>
-                  <a:srgbClr val="9DA9B5"/>
-                </a:solidFill>
-                <a:latin typeface="Arial"/>
-              </a:rPr>
-              <a:t> — the expert and the once-a-week reader don't want the same one.</a:t>
-            </a:r>
-          </a:p>
-        </p:txBody>
-      </p:sp>
-      <p:sp>
-        <p:nvSpPr>
-          <p:cNvPr id="7" name="TextBox 6"/>
+          </a:p>
+        </p:txBody>
+      </p:sp>
+      <p:sp>
+        <p:nvSpPr>
+          <p:cNvPr id="8" name="TextBox 7"/>
           <p:cNvSpPr txBox="1"/>
           <p:nvPr/>
         </p:nvSpPr>
         <p:spPr>
           <a:xfrm>
-            <a:off x="777240" y="3759707"/>
-            <a:ext cx="10607040" cy="574040"/>
+            <a:off x="1280160" y="2423160"/>
+            <a:ext cx="10104119" cy="1097280"/>
           </a:xfrm>
           <a:prstGeom prst="rect">
             <a:avLst/>
@@ -4360,95 +4411,83 @@
           <a:noFill/>
         </p:spPr>
         <p:txBody>
-          <a:bodyPr wrap="square" lIns="25400" rIns="25400" tIns="12700" bIns="12700">
-            <a:noAutofit/>
+          <a:bodyPr wrap="square" anchor="t" lIns="0" rIns="0" tIns="0" bIns="0">
+            <a:spAutoFit/>
           </a:bodyPr>
           <a:lstStyle/>
           <a:p>
             <a:pPr algn="l">
               <a:lnSpc>
-                <a:spcPct val="128000"/>
+                <a:spcPct val="134000"/>
               </a:lnSpc>
-              <a:spcAft>
-                <a:spcPts val="400"/>
-              </a:spcAft>
             </a:pPr>
             <a:r>
-              <a:rPr sz="1400" b="0">
-                <a:solidFill>
-                  <a:srgbClr val="9DA9B5"/>
+              <a:rPr sz="1500" b="1" i="0">
+                <a:solidFill>
+                  <a:srgbClr val="ECEFF3"/>
                 </a:solidFill>
                 <a:latin typeface="Arial"/>
               </a:rPr>
-              <a:t>2</a:t>
-            </a:r>
-            <a:r>
-              <a:rPr sz="1400" b="1">
-                <a:solidFill>
-                  <a:srgbClr val="ECEFF3"/>
+              <a:t>Operating points, not one threshold.  </a:t>
+            </a:r>
+            <a:r>
+              <a:rPr sz="1350" b="0" i="0">
+                <a:solidFill>
+                  <a:srgbClr val="9DA9B5"/>
                 </a:solidFill>
                 <a:latin typeface="Arial"/>
               </a:rPr>
-              <a:t>Multimodal — and soon.</a:t>
-            </a:r>
-            <a:r>
-              <a:rPr sz="1400" b="0">
-                <a:solidFill>
-                  <a:srgbClr val="9DA9B5"/>
+              <a:t>Sensitivity vs. false positives is a </a:t>
+            </a:r>
+            <a:r>
+              <a:rPr sz="1350" b="1" i="0">
+                <a:solidFill>
+                  <a:srgbClr val="ECEFF3"/>
                 </a:solidFill>
                 <a:latin typeface="Arial"/>
               </a:rPr>
-              <a:t> A model on imaging alone, or </a:t>
-            </a:r>
-            <a:r>
-              <a:rPr sz="1400" b="1">
-                <a:solidFill>
-                  <a:srgbClr val="ECEFF3"/>
+              <a:t>value judgment</a:t>
+            </a:r>
+            <a:r>
+              <a:rPr sz="1350" b="0" i="0">
+                <a:solidFill>
+                  <a:srgbClr val="9DA9B5"/>
                 </a:solidFill>
                 <a:latin typeface="Arial"/>
               </a:rPr>
-              <a:t>imaging plus basic clinical data</a:t>
-            </a:r>
-            <a:r>
-              <a:rPr sz="1400" b="0">
-                <a:solidFill>
-                  <a:srgbClr val="9DA9B5"/>
+              <a:t>, not a setting. Let a model run at a range of operating points, </a:t>
+            </a:r>
+            <a:r>
+              <a:rPr sz="1350" b="1" i="0">
+                <a:solidFill>
+                  <a:srgbClr val="ECEFF3"/>
                 </a:solidFill>
                 <a:latin typeface="Arial"/>
               </a:rPr>
-              <a:t>, will end in user frustration. The model a radiologist trusts pulls in </a:t>
-            </a:r>
-            <a:r>
-              <a:rPr sz="1400" b="1">
-                <a:solidFill>
-                  <a:srgbClr val="ECEFF3"/>
+              <a:t>tailored to the site and the radiologist</a:t>
+            </a:r>
+            <a:r>
+              <a:rPr sz="1350" b="0" i="0">
+                <a:solidFill>
+                  <a:srgbClr val="9DA9B5"/>
                 </a:solidFill>
                 <a:latin typeface="Arial"/>
               </a:rPr>
-              <a:t>image, clinical context, risk, and history</a:t>
-            </a:r>
-            <a:r>
-              <a:rPr sz="1400" b="0">
-                <a:solidFill>
-                  <a:srgbClr val="9DA9B5"/>
-                </a:solidFill>
-                <a:latin typeface="Arial"/>
-              </a:rPr>
-              <a:t> together.</a:t>
-            </a:r>
-          </a:p>
-        </p:txBody>
-      </p:sp>
-      <p:sp>
-        <p:nvSpPr>
-          <p:cNvPr id="8" name="TextBox 7"/>
+              <a:t> — the expert and the once-a-week reader don't want the same one.</a:t>
+            </a:r>
+          </a:p>
+        </p:txBody>
+      </p:sp>
+      <p:sp>
+        <p:nvSpPr>
+          <p:cNvPr id="9" name="TextBox 8"/>
           <p:cNvSpPr txBox="1"/>
           <p:nvPr/>
         </p:nvSpPr>
         <p:spPr>
           <a:xfrm>
-            <a:off x="777240" y="4333748"/>
-            <a:ext cx="10607040" cy="574040"/>
+            <a:off x="777240" y="3657600"/>
+            <a:ext cx="457200" cy="1005840"/>
           </a:xfrm>
           <a:prstGeom prst="rect">
             <a:avLst/>
@@ -4456,59 +4495,38 @@
           <a:noFill/>
         </p:spPr>
         <p:txBody>
-          <a:bodyPr wrap="square" lIns="25400" rIns="25400" tIns="12700" bIns="12700">
-            <a:noAutofit/>
+          <a:bodyPr wrap="square" anchor="t" lIns="0" rIns="0" tIns="0" bIns="0">
+            <a:spAutoFit/>
           </a:bodyPr>
           <a:lstStyle/>
           <a:p>
             <a:pPr algn="l">
               <a:lnSpc>
-                <a:spcPct val="128000"/>
+                <a:spcPct val="100000"/>
               </a:lnSpc>
-              <a:spcAft>
-                <a:spcPts val="400"/>
-              </a:spcAft>
             </a:pPr>
             <a:r>
-              <a:rPr sz="1400" b="0">
-                <a:solidFill>
-                  <a:srgbClr val="9DA9B5"/>
-                </a:solidFill>
-                <a:latin typeface="Arial"/>
+              <a:rPr sz="1500" b="1" i="0">
+                <a:solidFill>
+                  <a:srgbClr val="E7AC51"/>
+                </a:solidFill>
+                <a:latin typeface="Consolas"/>
               </a:rPr>
-              <a:t>3</a:t>
-            </a:r>
-            <a:r>
-              <a:rPr sz="1400" b="1">
-                <a:solidFill>
-                  <a:srgbClr val="ECEFF3"/>
-                </a:solidFill>
-                <a:latin typeface="Arial"/>
-              </a:rPr>
-              <a:t>The integration tax.</a:t>
-            </a:r>
-            <a:r>
-              <a:rPr sz="1400" b="0">
-                <a:solidFill>
-                  <a:srgbClr val="9DA9B5"/>
-                </a:solidFill>
-                <a:latin typeface="Arial"/>
-              </a:rPr>
-              <a:t> A perfect model dies if it can't reach PACS. One-off integrations don't scale; onboarding happens through a platform or vendor you already run.</a:t>
-            </a:r>
-          </a:p>
-        </p:txBody>
-      </p:sp>
-      <p:sp>
-        <p:nvSpPr>
-          <p:cNvPr id="9" name="TextBox 8"/>
+              <a:t>2</a:t>
+            </a:r>
+          </a:p>
+        </p:txBody>
+      </p:sp>
+      <p:sp>
+        <p:nvSpPr>
+          <p:cNvPr id="10" name="TextBox 9"/>
           <p:cNvSpPr txBox="1"/>
           <p:nvPr/>
         </p:nvSpPr>
         <p:spPr>
           <a:xfrm>
-            <a:off x="777240" y="4907788"/>
-            <a:ext cx="10607040" cy="421640"/>
+            <a:off x="1280160" y="3657600"/>
+            <a:ext cx="10104119" cy="1005840"/>
           </a:xfrm>
           <a:prstGeom prst="rect">
             <a:avLst/>
@@ -4516,27 +4534,195 @@
           <a:noFill/>
         </p:spPr>
         <p:txBody>
-          <a:bodyPr wrap="square" lIns="25400" rIns="25400" tIns="12700" bIns="12700">
-            <a:noAutofit/>
+          <a:bodyPr wrap="square" anchor="t" lIns="0" rIns="0" tIns="0" bIns="0">
+            <a:spAutoFit/>
           </a:bodyPr>
           <a:lstStyle/>
           <a:p>
             <a:pPr algn="l">
               <a:lnSpc>
-                <a:spcPct val="130000"/>
+                <a:spcPct val="134000"/>
               </a:lnSpc>
-              <a:spcAft>
-                <a:spcPts val="400"/>
-              </a:spcAft>
             </a:pPr>
             <a:r>
-              <a:rPr sz="1000" b="0">
-                <a:solidFill>
-                  <a:srgbClr val="5C6975"/>
+              <a:rPr sz="1500" b="1" i="0">
+                <a:solidFill>
+                  <a:srgbClr val="ECEFF3"/>
+                </a:solidFill>
+                <a:latin typeface="Arial"/>
+              </a:rPr>
+              <a:t>Multimodal — and soon.  </a:t>
+            </a:r>
+            <a:r>
+              <a:rPr sz="1350" b="0" i="0">
+                <a:solidFill>
+                  <a:srgbClr val="9DA9B5"/>
+                </a:solidFill>
+                <a:latin typeface="Arial"/>
+              </a:rPr>
+              <a:t>A model on imaging alone, or </a:t>
+            </a:r>
+            <a:r>
+              <a:rPr sz="1350" b="1" i="0">
+                <a:solidFill>
+                  <a:srgbClr val="ECEFF3"/>
+                </a:solidFill>
+                <a:latin typeface="Arial"/>
+              </a:rPr>
+              <a:t>imaging plus basic clinical data</a:t>
+            </a:r>
+            <a:r>
+              <a:rPr sz="1350" b="0" i="0">
+                <a:solidFill>
+                  <a:srgbClr val="9DA9B5"/>
+                </a:solidFill>
+                <a:latin typeface="Arial"/>
+              </a:rPr>
+              <a:t>, will end in user frustration. The model a radiologist trusts pulls in </a:t>
+            </a:r>
+            <a:r>
+              <a:rPr sz="1350" b="1" i="0">
+                <a:solidFill>
+                  <a:srgbClr val="ECEFF3"/>
+                </a:solidFill>
+                <a:latin typeface="Arial"/>
+              </a:rPr>
+              <a:t>image, clinical context, risk, and history</a:t>
+            </a:r>
+            <a:r>
+              <a:rPr sz="1350" b="0" i="0">
+                <a:solidFill>
+                  <a:srgbClr val="9DA9B5"/>
+                </a:solidFill>
+                <a:latin typeface="Arial"/>
+              </a:rPr>
+              <a:t> together.</a:t>
+            </a:r>
+          </a:p>
+        </p:txBody>
+      </p:sp>
+      <p:sp>
+        <p:nvSpPr>
+          <p:cNvPr id="11" name="TextBox 10"/>
+          <p:cNvSpPr txBox="1"/>
+          <p:nvPr/>
+        </p:nvSpPr>
+        <p:spPr>
+          <a:xfrm>
+            <a:off x="777240" y="4800600"/>
+            <a:ext cx="457200" cy="822960"/>
+          </a:xfrm>
+          <a:prstGeom prst="rect">
+            <a:avLst/>
+          </a:prstGeom>
+          <a:noFill/>
+        </p:spPr>
+        <p:txBody>
+          <a:bodyPr wrap="square" anchor="t" lIns="0" rIns="0" tIns="0" bIns="0">
+            <a:spAutoFit/>
+          </a:bodyPr>
+          <a:lstStyle/>
+          <a:p>
+            <a:pPr algn="l">
+              <a:lnSpc>
+                <a:spcPct val="100000"/>
+              </a:lnSpc>
+            </a:pPr>
+            <a:r>
+              <a:rPr sz="1500" b="1" i="0">
+                <a:solidFill>
+                  <a:srgbClr val="E7AC51"/>
                 </a:solidFill>
                 <a:latin typeface="Consolas"/>
               </a:rPr>
-              <a:t>Sharma N, et al. BMC Cancer 2023;23:460 (275,900 mammograms; multi-vendor) · Eisemann N, et al. Nat Med 2025;31:917–924 (PRAIM) · Tejani AS, et al. Radiology 2024;311:e232653 · Allen B, et al. Mayo Clin Proc Digit Health 2024;2(4)</a:t>
+              <a:t>3</a:t>
+            </a:r>
+          </a:p>
+        </p:txBody>
+      </p:sp>
+      <p:sp>
+        <p:nvSpPr>
+          <p:cNvPr id="12" name="TextBox 11"/>
+          <p:cNvSpPr txBox="1"/>
+          <p:nvPr/>
+        </p:nvSpPr>
+        <p:spPr>
+          <a:xfrm>
+            <a:off x="1280160" y="4800600"/>
+            <a:ext cx="10104119" cy="822960"/>
+          </a:xfrm>
+          <a:prstGeom prst="rect">
+            <a:avLst/>
+          </a:prstGeom>
+          <a:noFill/>
+        </p:spPr>
+        <p:txBody>
+          <a:bodyPr wrap="square" anchor="t" lIns="0" rIns="0" tIns="0" bIns="0">
+            <a:spAutoFit/>
+          </a:bodyPr>
+          <a:lstStyle/>
+          <a:p>
+            <a:pPr algn="l">
+              <a:lnSpc>
+                <a:spcPct val="134000"/>
+              </a:lnSpc>
+            </a:pPr>
+            <a:r>
+              <a:rPr sz="1500" b="1" i="0">
+                <a:solidFill>
+                  <a:srgbClr val="ECEFF3"/>
+                </a:solidFill>
+                <a:latin typeface="Arial"/>
+              </a:rPr>
+              <a:t>The integration tax.  </a:t>
+            </a:r>
+            <a:r>
+              <a:rPr sz="1350" b="0" i="0">
+                <a:solidFill>
+                  <a:srgbClr val="9DA9B5"/>
+                </a:solidFill>
+                <a:latin typeface="Arial"/>
+              </a:rPr>
+              <a:t>A perfect model dies if it can't reach PACS. One-off integrations don't scale; onboarding happens through a platform or vendor you already run.</a:t>
+            </a:r>
+          </a:p>
+        </p:txBody>
+      </p:sp>
+      <p:sp>
+        <p:nvSpPr>
+          <p:cNvPr id="13" name="TextBox 12"/>
+          <p:cNvSpPr txBox="1"/>
+          <p:nvPr/>
+        </p:nvSpPr>
+        <p:spPr>
+          <a:xfrm>
+            <a:off x="777240" y="6172200"/>
+            <a:ext cx="10607040" cy="365760"/>
+          </a:xfrm>
+          <a:prstGeom prst="rect">
+            <a:avLst/>
+          </a:prstGeom>
+          <a:noFill/>
+        </p:spPr>
+        <p:txBody>
+          <a:bodyPr wrap="square" anchor="t" lIns="0" rIns="0" tIns="0" bIns="0">
+            <a:spAutoFit/>
+          </a:bodyPr>
+          <a:lstStyle/>
+          <a:p>
+            <a:pPr algn="l">
+              <a:lnSpc>
+                <a:spcPct val="100000"/>
+              </a:lnSpc>
+            </a:pPr>
+            <a:r>
+              <a:rPr sz="900" b="0" i="0">
+                <a:solidFill>
+                  <a:srgbClr val="5C6975"/>
+                </a:solidFill>
+                <a:latin typeface="Consolas"/>
+              </a:rPr>
+              <a:t>Sharma, BMC Cancer 2023 (275,900 mammograms) · Eisemann, Nat Med 2025 (PRAIM) · Tejani, Radiology 2024 · Allen, Mayo Clin Proc Digit Health 2024</a:t>
             </a:r>
           </a:p>
         </p:txBody>

</xml_diff>

<commit_message>
Adoption + Close PPTX: rebuild via exact-layout extractor (HTML-measured positions/sizes/colors) — left margin 0.69, exact font pts, cyan highlights, amber callout/turn left-bars, Emory-navy EMORY; extractor now captures text-transform + left-border + padding
</commit_message>
<xml_diff>
--- a/keynote-iwbi-2026/pptx/sections/IWBI2026_Trivedi_06c_adoption.pptx
+++ b/keynote-iwbi-2026/pptx/sections/IWBI2026_Trivedi_06c_adoption.pptx
@@ -6,7 +6,7 @@
   </p:sldMasterIdLst>
   <p:sldIdLst>
     <p:sldId id="256" r:id="rId7"/>
-    <p:sldId id="257" r:id="rId9"/>
+    <p:sldId id="257" r:id="rId8"/>
   </p:sldIdLst>
   <p:sldSz cx="12191695" cy="6858000" type="screen4x3"/>
   <p:notesSz cx="6858000" cy="9144000"/>
@@ -106,496 +106,6 @@
     </a:lvl9pPr>
   </p:defaultTextStyle>
 </p:presentation>
-</file>
-
-<file path=ppt/notesMasters/notesMaster1.xml><?xml version="1.0" encoding="utf-8"?>
-<p:notesMaster xmlns:a="http://schemas.openxmlformats.org/drawingml/2006/main" xmlns:p="http://schemas.openxmlformats.org/presentationml/2006/main" xmlns:r="http://schemas.openxmlformats.org/officeDocument/2006/relationships">
-  <p:cSld>
-    <p:bg>
-      <p:bgRef idx="1001">
-        <a:schemeClr val="bg1"/>
-      </p:bgRef>
-    </p:bg>
-    <p:spTree>
-      <p:nvGrpSpPr>
-        <p:cNvPr id="1" name=""/>
-        <p:cNvGrpSpPr/>
-        <p:nvPr/>
-      </p:nvGrpSpPr>
-      <p:grpSpPr>
-        <a:xfrm>
-          <a:off x="0" y="0"/>
-          <a:ext cx="0" cy="0"/>
-          <a:chOff x="0" y="0"/>
-          <a:chExt cx="0" cy="0"/>
-        </a:xfrm>
-      </p:grpSpPr>
-      <p:sp>
-        <p:nvSpPr>
-          <p:cNvPr id="2" name="Header Placeholder 1"/>
-          <p:cNvSpPr>
-            <a:spLocks noGrp="1"/>
-          </p:cNvSpPr>
-          <p:nvPr>
-            <p:ph type="hdr" sz="quarter"/>
-          </p:nvPr>
-        </p:nvSpPr>
-        <p:spPr>
-          <a:xfrm>
-            <a:off x="0" y="0"/>
-            <a:ext cx="2971800" cy="457200"/>
-          </a:xfrm>
-          <a:prstGeom prst="rect">
-            <a:avLst/>
-          </a:prstGeom>
-        </p:spPr>
-        <p:txBody>
-          <a:bodyPr vert="horz" lIns="91440" tIns="45720" rIns="91440" bIns="45720" rtlCol="0"/>
-          <a:lstStyle>
-            <a:lvl1pPr algn="l">
-              <a:defRPr sz="1200"/>
-            </a:lvl1pPr>
-          </a:lstStyle>
-          <a:p>
-            <a:endParaRPr lang="en-US"/>
-          </a:p>
-        </p:txBody>
-      </p:sp>
-      <p:sp>
-        <p:nvSpPr>
-          <p:cNvPr id="3" name="Date Placeholder 2"/>
-          <p:cNvSpPr>
-            <a:spLocks noGrp="1"/>
-          </p:cNvSpPr>
-          <p:nvPr>
-            <p:ph type="dt" idx="1"/>
-          </p:nvPr>
-        </p:nvSpPr>
-        <p:spPr>
-          <a:xfrm>
-            <a:off x="3884613" y="0"/>
-            <a:ext cx="2971800" cy="457200"/>
-          </a:xfrm>
-          <a:prstGeom prst="rect">
-            <a:avLst/>
-          </a:prstGeom>
-        </p:spPr>
-        <p:txBody>
-          <a:bodyPr vert="horz" lIns="91440" tIns="45720" rIns="91440" bIns="45720" rtlCol="0"/>
-          <a:lstStyle>
-            <a:lvl1pPr algn="r">
-              <a:defRPr sz="1200"/>
-            </a:lvl1pPr>
-          </a:lstStyle>
-          <a:p>
-            <a:fld id="{0F89C1C7-3DCD-1040-A9CF-14679D8B5DDD}" type="datetimeFigureOut">
-              <a:rPr lang="en-US" smtClean="0"/>
-              <a:t>10/17/16</a:t>
-            </a:fld>
-            <a:endParaRPr lang="en-US"/>
-          </a:p>
-        </p:txBody>
-      </p:sp>
-      <p:sp>
-        <p:nvSpPr>
-          <p:cNvPr id="4" name="Slide Image Placeholder 3"/>
-          <p:cNvSpPr>
-            <a:spLocks noGrp="1" noRot="1" noChangeAspect="1"/>
-          </p:cNvSpPr>
-          <p:nvPr>
-            <p:ph type="sldImg" idx="2"/>
-          </p:nvPr>
-        </p:nvSpPr>
-        <p:spPr>
-          <a:xfrm>
-            <a:off x="1143000" y="685800"/>
-            <a:ext cx="4572000" cy="3429000"/>
-          </a:xfrm>
-          <a:prstGeom prst="rect">
-            <a:avLst/>
-          </a:prstGeom>
-          <a:noFill/>
-          <a:ln w="12700">
-            <a:solidFill>
-              <a:prstClr val="black"/>
-            </a:solidFill>
-          </a:ln>
-        </p:spPr>
-        <p:txBody>
-          <a:bodyPr vert="horz" lIns="91440" tIns="45720" rIns="91440" bIns="45720" rtlCol="0" anchor="ctr"/>
-          <a:lstStyle/>
-          <a:p>
-            <a:endParaRPr lang="en-US"/>
-          </a:p>
-        </p:txBody>
-      </p:sp>
-      <p:sp>
-        <p:nvSpPr>
-          <p:cNvPr id="5" name="Notes Placeholder 4"/>
-          <p:cNvSpPr>
-            <a:spLocks noGrp="1"/>
-          </p:cNvSpPr>
-          <p:nvPr>
-            <p:ph type="body" sz="quarter" idx="3"/>
-          </p:nvPr>
-        </p:nvSpPr>
-        <p:spPr>
-          <a:xfrm>
-            <a:off x="685800" y="4343400"/>
-            <a:ext cx="5486400" cy="4114800"/>
-          </a:xfrm>
-          <a:prstGeom prst="rect">
-            <a:avLst/>
-          </a:prstGeom>
-        </p:spPr>
-        <p:txBody>
-          <a:bodyPr vert="horz" lIns="91440" tIns="45720" rIns="91440" bIns="45720" rtlCol="0"/>
-          <a:lstStyle/>
-          <a:p>
-            <a:pPr lvl="0"/>
-            <a:r>
-              <a:rPr lang="en-US" smtClean="0"/>
-              <a:t>Click to edit Master text styles</a:t>
-            </a:r>
-          </a:p>
-          <a:p>
-            <a:pPr lvl="1"/>
-            <a:r>
-              <a:rPr lang="en-US" smtClean="0"/>
-              <a:t>Second level</a:t>
-            </a:r>
-          </a:p>
-          <a:p>
-            <a:pPr lvl="2"/>
-            <a:r>
-              <a:rPr lang="en-US" smtClean="0"/>
-              <a:t>Third level</a:t>
-            </a:r>
-          </a:p>
-          <a:p>
-            <a:pPr lvl="3"/>
-            <a:r>
-              <a:rPr lang="en-US" smtClean="0"/>
-              <a:t>Fourth level</a:t>
-            </a:r>
-          </a:p>
-          <a:p>
-            <a:pPr lvl="4"/>
-            <a:r>
-              <a:rPr lang="en-US" smtClean="0"/>
-              <a:t>Fifth level</a:t>
-            </a:r>
-            <a:endParaRPr lang="en-US"/>
-          </a:p>
-        </p:txBody>
-      </p:sp>
-      <p:sp>
-        <p:nvSpPr>
-          <p:cNvPr id="6" name="Footer Placeholder 5"/>
-          <p:cNvSpPr>
-            <a:spLocks noGrp="1"/>
-          </p:cNvSpPr>
-          <p:nvPr>
-            <p:ph type="ftr" sz="quarter" idx="4"/>
-          </p:nvPr>
-        </p:nvSpPr>
-        <p:spPr>
-          <a:xfrm>
-            <a:off x="0" y="8685213"/>
-            <a:ext cx="2971800" cy="457200"/>
-          </a:xfrm>
-          <a:prstGeom prst="rect">
-            <a:avLst/>
-          </a:prstGeom>
-        </p:spPr>
-        <p:txBody>
-          <a:bodyPr vert="horz" lIns="91440" tIns="45720" rIns="91440" bIns="45720" rtlCol="0" anchor="b"/>
-          <a:lstStyle>
-            <a:lvl1pPr algn="l">
-              <a:defRPr sz="1200"/>
-            </a:lvl1pPr>
-          </a:lstStyle>
-          <a:p>
-            <a:endParaRPr lang="en-US"/>
-          </a:p>
-        </p:txBody>
-      </p:sp>
-      <p:sp>
-        <p:nvSpPr>
-          <p:cNvPr id="7" name="Slide Number Placeholder 6"/>
-          <p:cNvSpPr>
-            <a:spLocks noGrp="1"/>
-          </p:cNvSpPr>
-          <p:nvPr>
-            <p:ph type="sldNum" sz="quarter" idx="5"/>
-          </p:nvPr>
-        </p:nvSpPr>
-        <p:spPr>
-          <a:xfrm>
-            <a:off x="3884613" y="8685213"/>
-            <a:ext cx="2971800" cy="457200"/>
-          </a:xfrm>
-          <a:prstGeom prst="rect">
-            <a:avLst/>
-          </a:prstGeom>
-        </p:spPr>
-        <p:txBody>
-          <a:bodyPr vert="horz" lIns="91440" tIns="45720" rIns="91440" bIns="45720" rtlCol="0" anchor="b"/>
-          <a:lstStyle>
-            <a:lvl1pPr algn="r">
-              <a:defRPr sz="1200"/>
-            </a:lvl1pPr>
-          </a:lstStyle>
-          <a:p>
-            <a:fld id="{BB5E49A5-4136-284D-997B-48E1D791AD67}" type="slidenum">
-              <a:rPr lang="en-US" smtClean="0"/>
-              <a:t>‹#›</a:t>
-            </a:fld>
-            <a:endParaRPr lang="en-US"/>
-          </a:p>
-        </p:txBody>
-      </p:sp>
-    </p:spTree>
-    <p:extLst>
-      <p:ext uri="{BB962C8B-B14F-4D97-AF65-F5344CB8AC3E}">
-        <p14:creationId xmlns:p14="http://schemas.microsoft.com/office/powerpoint/2010/main" val="2623252185"/>
-      </p:ext>
-    </p:extLst>
-  </p:cSld>
-  <p:clrMap bg1="lt1" tx1="dk1" bg2="lt2" tx2="dk2" accent1="accent1" accent2="accent2" accent3="accent3" accent4="accent4" accent5="accent5" accent6="accent6" hlink="hlink" folHlink="folHlink"/>
-  <p:notesStyle>
-    <a:lvl1pPr marL="0" algn="l" defTabSz="457200" rtl="0" eaLnBrk="1" latinLnBrk="0" hangingPunct="1">
-      <a:defRPr sz="1200" kern="1200">
-        <a:solidFill>
-          <a:schemeClr val="tx1"/>
-        </a:solidFill>
-        <a:latin typeface="+mn-lt"/>
-        <a:ea typeface="+mn-ea"/>
-        <a:cs typeface="+mn-cs"/>
-      </a:defRPr>
-    </a:lvl1pPr>
-    <a:lvl2pPr marL="457200" algn="l" defTabSz="457200" rtl="0" eaLnBrk="1" latinLnBrk="0" hangingPunct="1">
-      <a:defRPr sz="1200" kern="1200">
-        <a:solidFill>
-          <a:schemeClr val="tx1"/>
-        </a:solidFill>
-        <a:latin typeface="+mn-lt"/>
-        <a:ea typeface="+mn-ea"/>
-        <a:cs typeface="+mn-cs"/>
-      </a:defRPr>
-    </a:lvl2pPr>
-    <a:lvl3pPr marL="914400" algn="l" defTabSz="457200" rtl="0" eaLnBrk="1" latinLnBrk="0" hangingPunct="1">
-      <a:defRPr sz="1200" kern="1200">
-        <a:solidFill>
-          <a:schemeClr val="tx1"/>
-        </a:solidFill>
-        <a:latin typeface="+mn-lt"/>
-        <a:ea typeface="+mn-ea"/>
-        <a:cs typeface="+mn-cs"/>
-      </a:defRPr>
-    </a:lvl3pPr>
-    <a:lvl4pPr marL="1371600" algn="l" defTabSz="457200" rtl="0" eaLnBrk="1" latinLnBrk="0" hangingPunct="1">
-      <a:defRPr sz="1200" kern="1200">
-        <a:solidFill>
-          <a:schemeClr val="tx1"/>
-        </a:solidFill>
-        <a:latin typeface="+mn-lt"/>
-        <a:ea typeface="+mn-ea"/>
-        <a:cs typeface="+mn-cs"/>
-      </a:defRPr>
-    </a:lvl4pPr>
-    <a:lvl5pPr marL="1828800" algn="l" defTabSz="457200" rtl="0" eaLnBrk="1" latinLnBrk="0" hangingPunct="1">
-      <a:defRPr sz="1200" kern="1200">
-        <a:solidFill>
-          <a:schemeClr val="tx1"/>
-        </a:solidFill>
-        <a:latin typeface="+mn-lt"/>
-        <a:ea typeface="+mn-ea"/>
-        <a:cs typeface="+mn-cs"/>
-      </a:defRPr>
-    </a:lvl5pPr>
-    <a:lvl6pPr marL="2286000" algn="l" defTabSz="457200" rtl="0" eaLnBrk="1" latinLnBrk="0" hangingPunct="1">
-      <a:defRPr sz="1200" kern="1200">
-        <a:solidFill>
-          <a:schemeClr val="tx1"/>
-        </a:solidFill>
-        <a:latin typeface="+mn-lt"/>
-        <a:ea typeface="+mn-ea"/>
-        <a:cs typeface="+mn-cs"/>
-      </a:defRPr>
-    </a:lvl6pPr>
-    <a:lvl7pPr marL="2743200" algn="l" defTabSz="457200" rtl="0" eaLnBrk="1" latinLnBrk="0" hangingPunct="1">
-      <a:defRPr sz="1200" kern="1200">
-        <a:solidFill>
-          <a:schemeClr val="tx1"/>
-        </a:solidFill>
-        <a:latin typeface="+mn-lt"/>
-        <a:ea typeface="+mn-ea"/>
-        <a:cs typeface="+mn-cs"/>
-      </a:defRPr>
-    </a:lvl7pPr>
-    <a:lvl8pPr marL="3200400" algn="l" defTabSz="457200" rtl="0" eaLnBrk="1" latinLnBrk="0" hangingPunct="1">
-      <a:defRPr sz="1200" kern="1200">
-        <a:solidFill>
-          <a:schemeClr val="tx1"/>
-        </a:solidFill>
-        <a:latin typeface="+mn-lt"/>
-        <a:ea typeface="+mn-ea"/>
-        <a:cs typeface="+mn-cs"/>
-      </a:defRPr>
-    </a:lvl8pPr>
-    <a:lvl9pPr marL="3657600" algn="l" defTabSz="457200" rtl="0" eaLnBrk="1" latinLnBrk="0" hangingPunct="1">
-      <a:defRPr sz="1200" kern="1200">
-        <a:solidFill>
-          <a:schemeClr val="tx1"/>
-        </a:solidFill>
-        <a:latin typeface="+mn-lt"/>
-        <a:ea typeface="+mn-ea"/>
-        <a:cs typeface="+mn-cs"/>
-      </a:defRPr>
-    </a:lvl9pPr>
-  </p:notesStyle>
-</p:notesMaster>
-</file>
-
-<file path=ppt/notesSlides/notesSlide1.xml><?xml version="1.0" encoding="utf-8"?>
-<p:notes xmlns:a="http://schemas.openxmlformats.org/drawingml/2006/main" xmlns:p="http://schemas.openxmlformats.org/presentationml/2006/main" xmlns:r="http://schemas.openxmlformats.org/officeDocument/2006/relationships">
-  <p:cSld>
-    <p:spTree>
-      <p:nvGrpSpPr>
-        <p:cNvPr id="1" name=""/>
-        <p:cNvGrpSpPr/>
-        <p:nvPr/>
-      </p:nvGrpSpPr>
-      <p:grpSpPr>
-        <a:xfrm>
-          <a:off x="0" y="0"/>
-          <a:ext cx="0" cy="0"/>
-          <a:chOff x="0" y="0"/>
-          <a:chExt cx="0" cy="0"/>
-        </a:xfrm>
-      </p:grpSpPr>
-      <p:sp>
-        <p:nvSpPr>
-          <p:cNvPr id="2" name="Slide Image Placeholder 1"/>
-          <p:cNvSpPr>
-            <a:spLocks noGrp="1"/>
-          </p:cNvSpPr>
-          <p:nvPr>
-            <p:ph type="sldImg" idx="2"/>
-          </p:nvPr>
-        </p:nvSpPr>
-        <p:spPr/>
-      </p:sp>
-      <p:sp>
-        <p:nvSpPr>
-          <p:cNvPr id="3" name="Notes Placeholder 2"/>
-          <p:cNvSpPr>
-            <a:spLocks noGrp="1"/>
-          </p:cNvSpPr>
-          <p:nvPr>
-            <p:ph type="body" idx="3" sz="quarter"/>
-          </p:nvPr>
-        </p:nvSpPr>
-        <p:spPr/>
-        <p:txBody>
-          <a:bodyPr/>
-          <a:lstStyle/>
-          <a:p>
-            <a:r>
-              <a:t>Everything I have shown you works. But working in a paper is not the bar for getting into the clinic. Look at what we ask a single model to do, all at once: hold up across every scanner and vendor in the field; perform in women of all ages, all densities, all risk types; and serve both the expert breast radiologist and the generalist who reads mammography one day a week. Asking one model to do all of this at once is the wrong goal. We should seriously reframe how we consider mammography-model deployment.</a:t>
-            </a:r>
-          </a:p>
-        </p:txBody>
-      </p:sp>
-      <p:sp>
-        <p:nvSpPr>
-          <p:cNvPr id="4" name="Slide Number Placeholder 3"/>
-          <p:cNvSpPr>
-            <a:spLocks noGrp="1"/>
-          </p:cNvSpPr>
-          <p:nvPr>
-            <p:ph type="sldNum" idx="5" sz="quarter"/>
-          </p:nvPr>
-        </p:nvSpPr>
-        <p:spPr/>
-      </p:sp>
-    </p:spTree>
-  </p:cSld>
-  <p:clrMapOvr>
-    <a:masterClrMapping/>
-  </p:clrMapOvr>
-</p:notes>
-</file>
-
-<file path=ppt/notesSlides/notesSlide2.xml><?xml version="1.0" encoding="utf-8"?>
-<p:notes xmlns:a="http://schemas.openxmlformats.org/drawingml/2006/main" xmlns:p="http://schemas.openxmlformats.org/presentationml/2006/main" xmlns:r="http://schemas.openxmlformats.org/officeDocument/2006/relationships">
-  <p:cSld>
-    <p:spTree>
-      <p:nvGrpSpPr>
-        <p:cNvPr id="1" name=""/>
-        <p:cNvGrpSpPr/>
-        <p:nvPr/>
-      </p:nvGrpSpPr>
-      <p:grpSpPr>
-        <a:xfrm>
-          <a:off x="0" y="0"/>
-          <a:ext cx="0" cy="0"/>
-          <a:chOff x="0" y="0"/>
-          <a:chExt cx="0" cy="0"/>
-        </a:xfrm>
-      </p:grpSpPr>
-      <p:sp>
-        <p:nvSpPr>
-          <p:cNvPr id="2" name="Slide Image Placeholder 1"/>
-          <p:cNvSpPr>
-            <a:spLocks noGrp="1"/>
-          </p:cNvSpPr>
-          <p:nvPr>
-            <p:ph type="sldImg" idx="2"/>
-          </p:nvPr>
-        </p:nvSpPr>
-        <p:spPr/>
-      </p:sp>
-      <p:sp>
-        <p:nvSpPr>
-          <p:cNvPr id="3" name="Notes Placeholder 2"/>
-          <p:cNvSpPr>
-            <a:spLocks noGrp="1"/>
-          </p:cNvSpPr>
-          <p:nvPr>
-            <p:ph type="body" idx="3" sz="quarter"/>
-          </p:nvPr>
-        </p:nvSpPr>
-        <p:spPr/>
-        <p:txBody>
-          <a:bodyPr/>
-          <a:lstStyle/>
-          <a:p>
-            <a:r>
-              <a:t>So how should we think about deployment instead? Three reframes. First, operating points: there is no single right threshold. Sensitivity versus false positives is a value judgment, not a setting — so a model should be permitted to run at a range of operating points, tailored to the site and to the individual radiologist, rather than one point imposed on everyone. Second, multimodal, and it needs to happen as soon as possible. I will say it plainly: a model that operates only on imaging data — or imaging plus basic clinical data — will end in user frustration. The model the radiologist will actually trust pulls in image, clinical context, risk, and history together. Third, the integration tax: even a perfect model dies if it cannot get into PACS. Custom one-off integrations do not scale, and overloaded IT means onboarding only happens through a platform or vendor you already run. Put those together and the winning system is not the most accurate in a paper — it is the one tuned to the reader, that knows what they know, and that fires inside the workflow.</a:t>
-            </a:r>
-          </a:p>
-        </p:txBody>
-      </p:sp>
-      <p:sp>
-        <p:nvSpPr>
-          <p:cNvPr id="4" name="Slide Number Placeholder 3"/>
-          <p:cNvSpPr>
-            <a:spLocks noGrp="1"/>
-          </p:cNvSpPr>
-          <p:nvPr>
-            <p:ph type="sldNum" idx="5" sz="quarter"/>
-          </p:nvPr>
-        </p:nvSpPr>
-        <p:spPr/>
-      </p:sp>
-    </p:spTree>
-  </p:cSld>
-  <p:clrMapOvr>
-    <a:masterClrMapping/>
-  </p:clrMapOvr>
-</p:notes>
 </file>
 
 <file path=ppt/slideLayouts/slideLayout1.xml><?xml version="1.0" encoding="utf-8"?>
@@ -3663,8 +3173,8 @@
         </p:nvSpPr>
         <p:spPr>
           <a:xfrm>
-            <a:off x="777240" y="502920"/>
-            <a:ext cx="8229600" cy="320040"/>
+            <a:off x="639955" y="379644"/>
+            <a:ext cx="1980936" cy="175883"/>
           </a:xfrm>
           <a:prstGeom prst="rect">
             <a:avLst/>
@@ -3672,18 +3182,18 @@
           <a:noFill/>
         </p:spPr>
         <p:txBody>
-          <a:bodyPr wrap="square" anchor="t" lIns="0" rIns="0" tIns="0" bIns="0">
-            <a:spAutoFit/>
+          <a:bodyPr wrap="square" lIns="0" rIns="0" tIns="0" bIns="0">
+            <a:noAutofit/>
           </a:bodyPr>
           <a:lstStyle/>
           <a:p>
             <a:pPr algn="l">
               <a:lnSpc>
-                <a:spcPct val="100000"/>
+                <a:spcPct val="120000"/>
               </a:lnSpc>
             </a:pPr>
             <a:r>
-              <a:rPr sz="1100" b="1" i="0">
+              <a:rPr sz="874" b="1" i="0">
                 <a:solidFill>
                   <a:srgbClr val="E7AC51"/>
                 </a:solidFill>
@@ -3702,8 +3212,8 @@
         </p:nvSpPr>
         <p:spPr>
           <a:xfrm>
-            <a:off x="777240" y="960120"/>
-            <a:ext cx="10424160" cy="914400"/>
+            <a:off x="639955" y="1383667"/>
+            <a:ext cx="11368859" cy="842294"/>
           </a:xfrm>
           <a:prstGeom prst="rect">
             <a:avLst/>
@@ -3711,18 +3221,18 @@
           <a:noFill/>
         </p:spPr>
         <p:txBody>
-          <a:bodyPr wrap="square" anchor="t" lIns="0" rIns="0" tIns="0" bIns="0">
-            <a:spAutoFit/>
+          <a:bodyPr wrap="square" lIns="0" rIns="0" tIns="0" bIns="0">
+            <a:noAutofit/>
           </a:bodyPr>
           <a:lstStyle/>
           <a:p>
             <a:pPr algn="l">
               <a:lnSpc>
-                <a:spcPct val="110000"/>
+                <a:spcPct val="112000"/>
               </a:lnSpc>
             </a:pPr>
             <a:r>
-              <a:rPr sz="2700" b="1" i="0">
+              <a:rPr sz="2801" b="1" i="0">
                 <a:solidFill>
                   <a:srgbClr val="ECEFF3"/>
                 </a:solidFill>
@@ -3731,7 +3241,7 @@
               <a:t>One model for everything is </a:t>
             </a:r>
             <a:r>
-              <a:rPr sz="2700" b="1" i="0">
+              <a:rPr sz="2801" b="1" i="0">
                 <a:solidFill>
                   <a:srgbClr val="E7AC51"/>
                 </a:solidFill>
@@ -3750,8 +3260,8 @@
         </p:nvSpPr>
         <p:spPr>
           <a:xfrm>
-            <a:off x="777240" y="2011680"/>
-            <a:ext cx="10424160" cy="548640"/>
+            <a:off x="639955" y="2397181"/>
+            <a:ext cx="7633706" cy="633829"/>
           </a:xfrm>
           <a:prstGeom prst="rect">
             <a:avLst/>
@@ -3759,18 +3269,18 @@
           <a:noFill/>
         </p:spPr>
         <p:txBody>
-          <a:bodyPr wrap="square" anchor="t" lIns="0" rIns="0" tIns="0" bIns="0">
-            <a:spAutoFit/>
+          <a:bodyPr wrap="square" lIns="0" rIns="0" tIns="0" bIns="0">
+            <a:noAutofit/>
           </a:bodyPr>
           <a:lstStyle/>
           <a:p>
             <a:pPr algn="l">
               <a:lnSpc>
-                <a:spcPct val="135000"/>
+                <a:spcPct val="150000"/>
               </a:lnSpc>
             </a:pPr>
             <a:r>
-              <a:rPr sz="1500" b="0" i="0">
+              <a:rPr sz="1544" b="0" i="0">
                 <a:solidFill>
                   <a:srgbClr val="9DA9B5"/>
                 </a:solidFill>
@@ -3779,7 +3289,7 @@
               <a:t>We chased better detection for three decades. But look at what we ask a </a:t>
             </a:r>
             <a:r>
-              <a:rPr sz="1500" b="1" i="0">
+              <a:rPr sz="1544" b="1" i="0">
                 <a:solidFill>
                   <a:srgbClr val="ECEFF3"/>
                 </a:solidFill>
@@ -3788,7 +3298,7 @@
               <a:t>single</a:t>
             </a:r>
             <a:r>
-              <a:rPr sz="1500" b="0" i="0">
+              <a:rPr sz="1544" b="0" i="0">
                 <a:solidFill>
                   <a:srgbClr val="9DA9B5"/>
                 </a:solidFill>
@@ -3807,8 +3317,8 @@
         </p:nvSpPr>
         <p:spPr>
           <a:xfrm>
-            <a:off x="777240" y="2788920"/>
-            <a:ext cx="457200" cy="548640"/>
+            <a:off x="639955" y="3223924"/>
+            <a:ext cx="9021972" cy="316555"/>
           </a:xfrm>
           <a:prstGeom prst="rect">
             <a:avLst/>
@@ -3816,24 +3326,51 @@
           <a:noFill/>
         </p:spPr>
         <p:txBody>
-          <a:bodyPr wrap="square" anchor="t" lIns="0" rIns="0" tIns="0" bIns="0">
-            <a:spAutoFit/>
+          <a:bodyPr wrap="square" lIns="0" rIns="0" tIns="0" bIns="0">
+            <a:noAutofit/>
           </a:bodyPr>
           <a:lstStyle/>
           <a:p>
             <a:pPr algn="l">
               <a:lnSpc>
-                <a:spcPct val="100000"/>
+                <a:spcPct val="120000"/>
               </a:lnSpc>
             </a:pPr>
             <a:r>
-              <a:rPr sz="1500" b="1" i="0">
+              <a:rPr sz="1366" b="1" i="0">
                 <a:solidFill>
                   <a:srgbClr val="E7AC51"/>
                 </a:solidFill>
-                <a:latin typeface="Consolas"/>
+                <a:latin typeface="Arial"/>
               </a:rPr>
               <a:t>01</a:t>
+            </a:r>
+            <a:r>
+              <a:rPr sz="1366" b="0" i="0">
+                <a:solidFill>
+                  <a:srgbClr val="9DA9B5"/>
+                </a:solidFill>
+                <a:latin typeface="Arial"/>
+              </a:rPr>
+              <a:t>Hold up across </a:t>
+            </a:r>
+            <a:r>
+              <a:rPr sz="1366" b="1" i="0">
+                <a:solidFill>
+                  <a:srgbClr val="ECEFF3"/>
+                </a:solidFill>
+                <a:latin typeface="Arial"/>
+              </a:rPr>
+              <a:t>every scanner and vendor</a:t>
+            </a:r>
+            <a:r>
+              <a:rPr sz="1366" b="0" i="0">
+                <a:solidFill>
+                  <a:srgbClr val="9DA9B5"/>
+                </a:solidFill>
+                <a:latin typeface="Arial"/>
+              </a:rPr>
+              <a:t> in the field</a:t>
             </a:r>
           </a:p>
         </p:txBody>
@@ -3846,8 +3383,8 @@
         </p:nvSpPr>
         <p:spPr>
           <a:xfrm>
-            <a:off x="1280160" y="2788920"/>
-            <a:ext cx="9921240" cy="548640"/>
+            <a:off x="639955" y="3603229"/>
+            <a:ext cx="9021972" cy="316555"/>
           </a:xfrm>
           <a:prstGeom prst="rect">
             <a:avLst/>
@@ -3855,42 +3392,42 @@
           <a:noFill/>
         </p:spPr>
         <p:txBody>
-          <a:bodyPr wrap="square" anchor="t" lIns="0" rIns="0" tIns="0" bIns="0">
-            <a:spAutoFit/>
+          <a:bodyPr wrap="square" lIns="0" rIns="0" tIns="0" bIns="0">
+            <a:noAutofit/>
           </a:bodyPr>
           <a:lstStyle/>
           <a:p>
             <a:pPr algn="l">
               <a:lnSpc>
-                <a:spcPct val="134000"/>
+                <a:spcPct val="120000"/>
               </a:lnSpc>
             </a:pPr>
             <a:r>
-              <a:rPr sz="1500" b="1" i="0">
-                <a:solidFill>
-                  <a:srgbClr val="ECEFF3"/>
+              <a:rPr sz="1366" b="1" i="0">
+                <a:solidFill>
+                  <a:srgbClr val="E7AC51"/>
                 </a:solidFill>
                 <a:latin typeface="Arial"/>
               </a:rPr>
-              <a:t>Hold up across  </a:t>
-            </a:r>
-            <a:r>
-              <a:rPr sz="1350" b="1" i="0">
-                <a:solidFill>
-                  <a:srgbClr val="ECEFF3"/>
+              <a:t>02</a:t>
+            </a:r>
+            <a:r>
+              <a:rPr sz="1366" b="0" i="0">
+                <a:solidFill>
+                  <a:srgbClr val="9DA9B5"/>
                 </a:solidFill>
                 <a:latin typeface="Arial"/>
               </a:rPr>
-              <a:t>every scanner and vendor</a:t>
-            </a:r>
-            <a:r>
-              <a:rPr sz="1350" b="0" i="0">
-                <a:solidFill>
-                  <a:srgbClr val="9DA9B5"/>
+              <a:t>Perform in women of </a:t>
+            </a:r>
+            <a:r>
+              <a:rPr sz="1366" b="1" i="0">
+                <a:solidFill>
+                  <a:srgbClr val="ECEFF3"/>
                 </a:solidFill>
                 <a:latin typeface="Arial"/>
               </a:rPr>
-              <a:t> in the field</a:t>
+              <a:t>all ages, all densities, all risk types</a:t>
             </a:r>
           </a:p>
         </p:txBody>
@@ -3903,8 +3440,8 @@
         </p:nvSpPr>
         <p:spPr>
           <a:xfrm>
-            <a:off x="777240" y="3429000"/>
-            <a:ext cx="457200" cy="548640"/>
+            <a:off x="639955" y="3982534"/>
+            <a:ext cx="8107572" cy="587390"/>
           </a:xfrm>
           <a:prstGeom prst="rect">
             <a:avLst/>
@@ -3912,38 +3449,118 @@
           <a:noFill/>
         </p:spPr>
         <p:txBody>
-          <a:bodyPr wrap="square" anchor="t" lIns="0" rIns="0" tIns="0" bIns="0">
-            <a:spAutoFit/>
+          <a:bodyPr wrap="square" lIns="0" rIns="0" tIns="0" bIns="0">
+            <a:noAutofit/>
           </a:bodyPr>
           <a:lstStyle/>
           <a:p>
             <a:pPr algn="l">
               <a:lnSpc>
-                <a:spcPct val="100000"/>
+                <a:spcPct val="120000"/>
               </a:lnSpc>
             </a:pPr>
             <a:r>
-              <a:rPr sz="1500" b="1" i="0">
+              <a:rPr sz="1366" b="1" i="0">
                 <a:solidFill>
                   <a:srgbClr val="E7AC51"/>
                 </a:solidFill>
-                <a:latin typeface="Consolas"/>
+                <a:latin typeface="Arial"/>
               </a:rPr>
-              <a:t>02</a:t>
-            </a:r>
-          </a:p>
-        </p:txBody>
-      </p:sp>
-      <p:sp>
-        <p:nvSpPr>
-          <p:cNvPr id="10" name="TextBox 9"/>
+              <a:t>03</a:t>
+            </a:r>
+            <a:r>
+              <a:rPr sz="1366" b="0" i="0">
+                <a:solidFill>
+                  <a:srgbClr val="9DA9B5"/>
+                </a:solidFill>
+                <a:latin typeface="Arial"/>
+              </a:rPr>
+              <a:t>Serve both the </a:t>
+            </a:r>
+            <a:r>
+              <a:rPr sz="1366" b="1" i="0">
+                <a:solidFill>
+                  <a:srgbClr val="ECEFF3"/>
+                </a:solidFill>
+                <a:latin typeface="Arial"/>
+              </a:rPr>
+              <a:t>expert breast radiologist</a:t>
+            </a:r>
+            <a:r>
+              <a:rPr sz="1366" b="0" i="0">
+                <a:solidFill>
+                  <a:srgbClr val="9DA9B5"/>
+                </a:solidFill>
+                <a:latin typeface="Arial"/>
+              </a:rPr>
+              <a:t> and the </a:t>
+            </a:r>
+            <a:r>
+              <a:rPr sz="1366" b="1" i="0">
+                <a:solidFill>
+                  <a:srgbClr val="ECEFF3"/>
+                </a:solidFill>
+                <a:latin typeface="Arial"/>
+              </a:rPr>
+              <a:t>generalist who reads mammo one day a week</a:t>
+            </a:r>
+          </a:p>
+        </p:txBody>
+      </p:sp>
+      <p:sp>
+        <p:nvSpPr>
+          <p:cNvPr id="10" name="Rectangle 9"/>
+          <p:cNvSpPr/>
+          <p:nvPr/>
+        </p:nvSpPr>
+        <p:spPr>
+          <a:xfrm>
+            <a:off x="639955" y="4784532"/>
+            <a:ext cx="27432" cy="689799"/>
+          </a:xfrm>
+          <a:prstGeom prst="rect">
+            <a:avLst/>
+          </a:prstGeom>
+          <a:solidFill>
+            <a:srgbClr val="E7AC51"/>
+          </a:solidFill>
+          <a:ln>
+            <a:noFill/>
+          </a:ln>
+          <a:effectLst/>
+        </p:spPr>
+        <p:style>
+          <a:lnRef idx="1">
+            <a:schemeClr val="accent1"/>
+          </a:lnRef>
+          <a:fillRef idx="3">
+            <a:schemeClr val="accent1"/>
+          </a:fillRef>
+          <a:effectRef idx="2">
+            <a:schemeClr val="accent1"/>
+          </a:effectRef>
+          <a:fontRef idx="minor">
+            <a:schemeClr val="lt1"/>
+          </a:fontRef>
+        </p:style>
+        <p:txBody>
+          <a:bodyPr rtlCol="0" anchor="ctr"/>
+          <a:lstStyle/>
+          <a:p>
+            <a:pPr algn="ctr"/>
+          </a:p>
+        </p:txBody>
+      </p:sp>
+      <p:sp>
+        <p:nvSpPr>
+          <p:cNvPr id="11" name="TextBox 10"/>
           <p:cNvSpPr txBox="1"/>
           <p:nvPr/>
         </p:nvSpPr>
         <p:spPr>
           <a:xfrm>
-            <a:off x="1280160" y="3429000"/>
-            <a:ext cx="9921240" cy="548640"/>
+            <a:off x="856889" y="4784532"/>
+            <a:ext cx="8554151" cy="735519"/>
           </a:xfrm>
           <a:prstGeom prst="rect">
             <a:avLst/>
@@ -3951,180 +3568,27 @@
           <a:noFill/>
         </p:spPr>
         <p:txBody>
-          <a:bodyPr wrap="square" anchor="t" lIns="0" rIns="0" tIns="0" bIns="0">
-            <a:spAutoFit/>
+          <a:bodyPr wrap="square" lIns="0" rIns="0" tIns="0" bIns="0">
+            <a:noAutofit/>
           </a:bodyPr>
           <a:lstStyle/>
           <a:p>
             <a:pPr algn="l">
               <a:lnSpc>
-                <a:spcPct val="134000"/>
+                <a:spcPct val="140000"/>
               </a:lnSpc>
             </a:pPr>
             <a:r>
-              <a:rPr sz="1500" b="1" i="0">
+              <a:rPr sz="1940" b="0" i="0">
                 <a:solidFill>
                   <a:srgbClr val="ECEFF3"/>
-                </a:solidFill>
-                <a:latin typeface="Arial"/>
-              </a:rPr>
-              <a:t>Perform in women of  </a:t>
-            </a:r>
-            <a:r>
-              <a:rPr sz="1350" b="1" i="0">
-                <a:solidFill>
-                  <a:srgbClr val="ECEFF3"/>
-                </a:solidFill>
-                <a:latin typeface="Arial"/>
-              </a:rPr>
-              <a:t>all ages, all densities, all risk types</a:t>
-            </a:r>
-          </a:p>
-        </p:txBody>
-      </p:sp>
-      <p:sp>
-        <p:nvSpPr>
-          <p:cNvPr id="11" name="TextBox 10"/>
-          <p:cNvSpPr txBox="1"/>
-          <p:nvPr/>
-        </p:nvSpPr>
-        <p:spPr>
-          <a:xfrm>
-            <a:off x="777240" y="4069080"/>
-            <a:ext cx="457200" cy="731520"/>
-          </a:xfrm>
-          <a:prstGeom prst="rect">
-            <a:avLst/>
-          </a:prstGeom>
-          <a:noFill/>
-        </p:spPr>
-        <p:txBody>
-          <a:bodyPr wrap="square" anchor="t" lIns="0" rIns="0" tIns="0" bIns="0">
-            <a:spAutoFit/>
-          </a:bodyPr>
-          <a:lstStyle/>
-          <a:p>
-            <a:pPr algn="l">
-              <a:lnSpc>
-                <a:spcPct val="100000"/>
-              </a:lnSpc>
-            </a:pPr>
-            <a:r>
-              <a:rPr sz="1500" b="1" i="0">
-                <a:solidFill>
-                  <a:srgbClr val="E7AC51"/>
-                </a:solidFill>
-                <a:latin typeface="Consolas"/>
-              </a:rPr>
-              <a:t>03</a:t>
-            </a:r>
-          </a:p>
-        </p:txBody>
-      </p:sp>
-      <p:sp>
-        <p:nvSpPr>
-          <p:cNvPr id="12" name="TextBox 11"/>
-          <p:cNvSpPr txBox="1"/>
-          <p:nvPr/>
-        </p:nvSpPr>
-        <p:spPr>
-          <a:xfrm>
-            <a:off x="1280160" y="4069080"/>
-            <a:ext cx="9921240" cy="731520"/>
-          </a:xfrm>
-          <a:prstGeom prst="rect">
-            <a:avLst/>
-          </a:prstGeom>
-          <a:noFill/>
-        </p:spPr>
-        <p:txBody>
-          <a:bodyPr wrap="square" anchor="t" lIns="0" rIns="0" tIns="0" bIns="0">
-            <a:spAutoFit/>
-          </a:bodyPr>
-          <a:lstStyle/>
-          <a:p>
-            <a:pPr algn="l">
-              <a:lnSpc>
-                <a:spcPct val="134000"/>
-              </a:lnSpc>
-            </a:pPr>
-            <a:r>
-              <a:rPr sz="1500" b="1" i="0">
-                <a:solidFill>
-                  <a:srgbClr val="ECEFF3"/>
-                </a:solidFill>
-                <a:latin typeface="Arial"/>
-              </a:rPr>
-              <a:t>Serve both the  </a:t>
-            </a:r>
-            <a:r>
-              <a:rPr sz="1350" b="1" i="0">
-                <a:solidFill>
-                  <a:srgbClr val="ECEFF3"/>
-                </a:solidFill>
-                <a:latin typeface="Arial"/>
-              </a:rPr>
-              <a:t>expert breast radiologist</a:t>
-            </a:r>
-            <a:r>
-              <a:rPr sz="1350" b="0" i="0">
-                <a:solidFill>
-                  <a:srgbClr val="9DA9B5"/>
-                </a:solidFill>
-                <a:latin typeface="Arial"/>
-              </a:rPr>
-              <a:t> and the </a:t>
-            </a:r>
-            <a:r>
-              <a:rPr sz="1350" b="1" i="0">
-                <a:solidFill>
-                  <a:srgbClr val="ECEFF3"/>
-                </a:solidFill>
-                <a:latin typeface="Arial"/>
-              </a:rPr>
-              <a:t>generalist who reads mammo one day a week</a:t>
-            </a:r>
-          </a:p>
-        </p:txBody>
-      </p:sp>
-      <p:sp>
-        <p:nvSpPr>
-          <p:cNvPr id="13" name="TextBox 12"/>
-          <p:cNvSpPr txBox="1"/>
-          <p:nvPr/>
-        </p:nvSpPr>
-        <p:spPr>
-          <a:xfrm>
-            <a:off x="777240" y="5029200"/>
-            <a:ext cx="10424160" cy="640080"/>
-          </a:xfrm>
-          <a:prstGeom prst="rect">
-            <a:avLst/>
-          </a:prstGeom>
-          <a:noFill/>
-        </p:spPr>
-        <p:txBody>
-          <a:bodyPr wrap="square" anchor="t" lIns="0" rIns="0" tIns="0" bIns="0">
-            <a:spAutoFit/>
-          </a:bodyPr>
-          <a:lstStyle/>
-          <a:p>
-            <a:pPr algn="l">
-              <a:lnSpc>
-                <a:spcPct val="135000"/>
-              </a:lnSpc>
-            </a:pPr>
-            <a:r>
-              <a:rPr sz="1600" b="0" i="0">
-                <a:solidFill>
-                  <a:srgbClr val="9DA9B5"/>
                 </a:solidFill>
                 <a:latin typeface="Arial"/>
               </a:rPr>
               <a:t>We should seriously reframe how we consider </a:t>
             </a:r>
             <a:r>
-              <a:rPr sz="1600" b="1" i="0">
+              <a:rPr sz="1940" b="1" i="0">
                 <a:solidFill>
                   <a:srgbClr val="E7AC51"/>
                 </a:solidFill>
@@ -4237,8 +3701,8 @@
         </p:nvSpPr>
         <p:spPr>
           <a:xfrm>
-            <a:off x="777240" y="502920"/>
-            <a:ext cx="8229600" cy="320040"/>
+            <a:off x="639955" y="379644"/>
+            <a:ext cx="1980936" cy="175883"/>
           </a:xfrm>
           <a:prstGeom prst="rect">
             <a:avLst/>
@@ -4246,18 +3710,18 @@
           <a:noFill/>
         </p:spPr>
         <p:txBody>
-          <a:bodyPr wrap="square" anchor="t" lIns="0" rIns="0" tIns="0" bIns="0">
-            <a:spAutoFit/>
+          <a:bodyPr wrap="square" lIns="0" rIns="0" tIns="0" bIns="0">
+            <a:noAutofit/>
           </a:bodyPr>
           <a:lstStyle/>
           <a:p>
             <a:pPr algn="l">
               <a:lnSpc>
-                <a:spcPct val="100000"/>
+                <a:spcPct val="120000"/>
               </a:lnSpc>
             </a:pPr>
             <a:r>
-              <a:rPr sz="1100" b="1" i="0">
+              <a:rPr sz="874" b="1" i="0">
                 <a:solidFill>
                   <a:srgbClr val="E7AC51"/>
                 </a:solidFill>
@@ -4276,8 +3740,8 @@
         </p:nvSpPr>
         <p:spPr>
           <a:xfrm>
-            <a:off x="777240" y="868680"/>
-            <a:ext cx="10424160" cy="914400"/>
+            <a:off x="639955" y="1258418"/>
+            <a:ext cx="11368859" cy="444007"/>
           </a:xfrm>
           <a:prstGeom prst="rect">
             <a:avLst/>
@@ -4285,18 +3749,18 @@
           <a:noFill/>
         </p:spPr>
         <p:txBody>
-          <a:bodyPr wrap="square" anchor="t" lIns="0" rIns="0" tIns="0" bIns="0">
-            <a:spAutoFit/>
+          <a:bodyPr wrap="square" lIns="0" rIns="0" tIns="0" bIns="0">
+            <a:noAutofit/>
           </a:bodyPr>
           <a:lstStyle/>
           <a:p>
             <a:pPr algn="l">
               <a:lnSpc>
-                <a:spcPct val="110000"/>
+                <a:spcPct val="112000"/>
               </a:lnSpc>
             </a:pPr>
             <a:r>
-              <a:rPr sz="2700" b="1" i="0">
+              <a:rPr sz="2801" b="1" i="0">
                 <a:solidFill>
                   <a:srgbClr val="ECEFF3"/>
                 </a:solidFill>
@@ -4305,7 +3769,7 @@
               <a:t>How we should deploy </a:t>
             </a:r>
             <a:r>
-              <a:rPr sz="2700" b="1" i="0">
+              <a:rPr sz="2801" b="1" i="0">
                 <a:solidFill>
                   <a:srgbClr val="E7AC51"/>
                 </a:solidFill>
@@ -4324,8 +3788,8 @@
         </p:nvSpPr>
         <p:spPr>
           <a:xfrm>
-            <a:off x="777240" y="1828800"/>
-            <a:ext cx="10424160" cy="365760"/>
+            <a:off x="639955" y="1873645"/>
+            <a:ext cx="8548106" cy="339774"/>
           </a:xfrm>
           <a:prstGeom prst="rect">
             <a:avLst/>
@@ -4333,18 +3797,18 @@
           <a:noFill/>
         </p:spPr>
         <p:txBody>
-          <a:bodyPr wrap="square" anchor="t" lIns="0" rIns="0" tIns="0" bIns="0">
-            <a:spAutoFit/>
+          <a:bodyPr wrap="square" lIns="0" rIns="0" tIns="0" bIns="0">
+            <a:noAutofit/>
           </a:bodyPr>
           <a:lstStyle/>
           <a:p>
             <a:pPr algn="l">
               <a:lnSpc>
-                <a:spcPct val="100000"/>
+                <a:spcPct val="150000"/>
               </a:lnSpc>
             </a:pPr>
             <a:r>
-              <a:rPr sz="1400" b="0" i="0">
+              <a:rPr sz="1544" b="0" i="0">
                 <a:solidFill>
                   <a:srgbClr val="9DA9B5"/>
                 </a:solidFill>
@@ -4363,8 +3827,8 @@
         </p:nvSpPr>
         <p:spPr>
           <a:xfrm>
-            <a:off x="777240" y="2423160"/>
-            <a:ext cx="457200" cy="1097280"/>
+            <a:off x="639955" y="2406333"/>
+            <a:ext cx="8107572" cy="858226"/>
           </a:xfrm>
           <a:prstGeom prst="rect">
             <a:avLst/>
@@ -4372,24 +3836,78 @@
           <a:noFill/>
         </p:spPr>
         <p:txBody>
-          <a:bodyPr wrap="square" anchor="t" lIns="0" rIns="0" tIns="0" bIns="0">
-            <a:spAutoFit/>
+          <a:bodyPr wrap="square" lIns="0" rIns="0" tIns="0" bIns="0">
+            <a:noAutofit/>
           </a:bodyPr>
           <a:lstStyle/>
           <a:p>
             <a:pPr algn="l">
               <a:lnSpc>
-                <a:spcPct val="100000"/>
+                <a:spcPct val="120000"/>
               </a:lnSpc>
             </a:pPr>
             <a:r>
-              <a:rPr sz="1500" b="1" i="0">
+              <a:rPr sz="1366" b="1" i="0">
                 <a:solidFill>
                   <a:srgbClr val="E7AC51"/>
                 </a:solidFill>
-                <a:latin typeface="Consolas"/>
+                <a:latin typeface="Arial"/>
               </a:rPr>
               <a:t>1</a:t>
+            </a:r>
+            <a:r>
+              <a:rPr sz="1366" b="1" i="0">
+                <a:solidFill>
+                  <a:srgbClr val="ECEFF3"/>
+                </a:solidFill>
+                <a:latin typeface="Arial"/>
+              </a:rPr>
+              <a:t>Operating points, not one threshold.</a:t>
+            </a:r>
+            <a:r>
+              <a:rPr sz="1366" b="0" i="0">
+                <a:solidFill>
+                  <a:srgbClr val="9DA9B5"/>
+                </a:solidFill>
+                <a:latin typeface="Arial"/>
+              </a:rPr>
+              <a:t> Sensitivity vs. false positives is a </a:t>
+            </a:r>
+            <a:r>
+              <a:rPr sz="1366" b="1" i="0">
+                <a:solidFill>
+                  <a:srgbClr val="ECEFF3"/>
+                </a:solidFill>
+                <a:latin typeface="Arial"/>
+              </a:rPr>
+              <a:t>value judgment</a:t>
+            </a:r>
+            <a:r>
+              <a:rPr sz="1366" b="0" i="0">
+                <a:solidFill>
+                  <a:srgbClr val="9DA9B5"/>
+                </a:solidFill>
+                <a:latin typeface="Arial"/>
+              </a:rPr>
+              <a:t>, not a setting. Let a model run at a range of operating points, </a:t>
+            </a:r>
+            <a:r>
+              <a:rPr sz="1366" b="1" i="0">
+                <a:solidFill>
+                  <a:srgbClr val="5FB7C9"/>
+                </a:solidFill>
+                <a:latin typeface="Arial"/>
+              </a:rPr>
+              <a:t>tailored to the site and the radiologist</a:t>
+            </a:r>
+            <a:r>
+              <a:rPr sz="1366" b="0" i="0">
+                <a:solidFill>
+                  <a:srgbClr val="9DA9B5"/>
+                </a:solidFill>
+                <a:latin typeface="Arial"/>
+              </a:rPr>
+              <a:t> — the expert and the once-a-week reader don't want the same one.</a:t>
             </a:r>
           </a:p>
         </p:txBody>
@@ -4402,8 +3920,8 @@
         </p:nvSpPr>
         <p:spPr>
           <a:xfrm>
-            <a:off x="1280160" y="2423160"/>
-            <a:ext cx="10104119" cy="1097280"/>
+            <a:off x="639955" y="3327309"/>
+            <a:ext cx="8107572" cy="858226"/>
           </a:xfrm>
           <a:prstGeom prst="rect">
             <a:avLst/>
@@ -4411,69 +3929,78 @@
           <a:noFill/>
         </p:spPr>
         <p:txBody>
-          <a:bodyPr wrap="square" anchor="t" lIns="0" rIns="0" tIns="0" bIns="0">
-            <a:spAutoFit/>
+          <a:bodyPr wrap="square" lIns="0" rIns="0" tIns="0" bIns="0">
+            <a:noAutofit/>
           </a:bodyPr>
           <a:lstStyle/>
           <a:p>
             <a:pPr algn="l">
               <a:lnSpc>
-                <a:spcPct val="134000"/>
+                <a:spcPct val="120000"/>
               </a:lnSpc>
             </a:pPr>
             <a:r>
-              <a:rPr sz="1500" b="1" i="0">
-                <a:solidFill>
-                  <a:srgbClr val="ECEFF3"/>
+              <a:rPr sz="1366" b="1" i="0">
+                <a:solidFill>
+                  <a:srgbClr val="E7AC51"/>
                 </a:solidFill>
                 <a:latin typeface="Arial"/>
               </a:rPr>
-              <a:t>Operating points, not one threshold.  </a:t>
-            </a:r>
-            <a:r>
-              <a:rPr sz="1350" b="0" i="0">
-                <a:solidFill>
-                  <a:srgbClr val="9DA9B5"/>
+              <a:t>2</a:t>
+            </a:r>
+            <a:r>
+              <a:rPr sz="1366" b="1" i="0">
+                <a:solidFill>
+                  <a:srgbClr val="ECEFF3"/>
                 </a:solidFill>
                 <a:latin typeface="Arial"/>
               </a:rPr>
-              <a:t>Sensitivity vs. false positives is a </a:t>
-            </a:r>
-            <a:r>
-              <a:rPr sz="1350" b="1" i="0">
-                <a:solidFill>
-                  <a:srgbClr val="ECEFF3"/>
+              <a:t>Multimodal — and soon.</a:t>
+            </a:r>
+            <a:r>
+              <a:rPr sz="1366" b="0" i="0">
+                <a:solidFill>
+                  <a:srgbClr val="9DA9B5"/>
                 </a:solidFill>
                 <a:latin typeface="Arial"/>
               </a:rPr>
-              <a:t>value judgment</a:t>
-            </a:r>
-            <a:r>
-              <a:rPr sz="1350" b="0" i="0">
-                <a:solidFill>
-                  <a:srgbClr val="9DA9B5"/>
+              <a:t> A model on imaging alone, or </a:t>
+            </a:r>
+            <a:r>
+              <a:rPr sz="1366" b="1" i="0">
+                <a:solidFill>
+                  <a:srgbClr val="ECEFF3"/>
                 </a:solidFill>
                 <a:latin typeface="Arial"/>
               </a:rPr>
-              <a:t>, not a setting. Let a model run at a range of operating points, </a:t>
-            </a:r>
-            <a:r>
-              <a:rPr sz="1350" b="1" i="0">
-                <a:solidFill>
-                  <a:srgbClr val="ECEFF3"/>
+              <a:t>imaging plus basic clinical data</a:t>
+            </a:r>
+            <a:r>
+              <a:rPr sz="1366" b="0" i="0">
+                <a:solidFill>
+                  <a:srgbClr val="9DA9B5"/>
                 </a:solidFill>
                 <a:latin typeface="Arial"/>
               </a:rPr>
-              <a:t>tailored to the site and the radiologist</a:t>
-            </a:r>
-            <a:r>
-              <a:rPr sz="1350" b="0" i="0">
-                <a:solidFill>
-                  <a:srgbClr val="9DA9B5"/>
+              <a:t>, will end in user frustration. The model a radiologist trusts pulls in </a:t>
+            </a:r>
+            <a:r>
+              <a:rPr sz="1366" b="1" i="0">
+                <a:solidFill>
+                  <a:srgbClr val="5FB7C9"/>
                 </a:solidFill>
                 <a:latin typeface="Arial"/>
               </a:rPr>
-              <a:t> — the expert and the once-a-week reader don't want the same one.</a:t>
+              <a:t>image, clinical context, risk, and history</a:t>
+            </a:r>
+            <a:r>
+              <a:rPr sz="1366" b="0" i="0">
+                <a:solidFill>
+                  <a:srgbClr val="9DA9B5"/>
+                </a:solidFill>
+                <a:latin typeface="Arial"/>
+              </a:rPr>
+              <a:t> together.</a:t>
             </a:r>
           </a:p>
         </p:txBody>
@@ -4486,8 +4013,8 @@
         </p:nvSpPr>
         <p:spPr>
           <a:xfrm>
-            <a:off x="777240" y="3657600"/>
-            <a:ext cx="457200" cy="1005840"/>
+            <a:off x="639955" y="4248285"/>
+            <a:ext cx="8107572" cy="587390"/>
           </a:xfrm>
           <a:prstGeom prst="rect">
             <a:avLst/>
@@ -4495,24 +4022,42 @@
           <a:noFill/>
         </p:spPr>
         <p:txBody>
-          <a:bodyPr wrap="square" anchor="t" lIns="0" rIns="0" tIns="0" bIns="0">
-            <a:spAutoFit/>
+          <a:bodyPr wrap="square" lIns="0" rIns="0" tIns="0" bIns="0">
+            <a:noAutofit/>
           </a:bodyPr>
           <a:lstStyle/>
           <a:p>
             <a:pPr algn="l">
               <a:lnSpc>
-                <a:spcPct val="100000"/>
+                <a:spcPct val="120000"/>
               </a:lnSpc>
             </a:pPr>
             <a:r>
-              <a:rPr sz="1500" b="1" i="0">
+              <a:rPr sz="1366" b="1" i="0">
                 <a:solidFill>
                   <a:srgbClr val="E7AC51"/>
                 </a:solidFill>
-                <a:latin typeface="Consolas"/>
+                <a:latin typeface="Arial"/>
               </a:rPr>
-              <a:t>2</a:t>
+              <a:t>3</a:t>
+            </a:r>
+            <a:r>
+              <a:rPr sz="1366" b="1" i="0">
+                <a:solidFill>
+                  <a:srgbClr val="ECEFF3"/>
+                </a:solidFill>
+                <a:latin typeface="Arial"/>
+              </a:rPr>
+              <a:t>The integration tax.</a:t>
+            </a:r>
+            <a:r>
+              <a:rPr sz="1366" b="0" i="0">
+                <a:solidFill>
+                  <a:srgbClr val="9DA9B5"/>
+                </a:solidFill>
+                <a:latin typeface="Arial"/>
+              </a:rPr>
+              <a:t> A perfect model dies if it can't reach PACS. One-off integrations don't scale; onboarding happens through a platform or vendor you already run.</a:t>
             </a:r>
           </a:p>
         </p:txBody>
@@ -4525,8 +4070,8 @@
         </p:nvSpPr>
         <p:spPr>
           <a:xfrm>
-            <a:off x="1280160" y="3657600"/>
-            <a:ext cx="10104119" cy="1005840"/>
+            <a:off x="639955" y="5115365"/>
+            <a:ext cx="5822137" cy="529766"/>
           </a:xfrm>
           <a:prstGeom prst="rect">
             <a:avLst/>
@@ -4534,195 +4079,24 @@
           <a:noFill/>
         </p:spPr>
         <p:txBody>
-          <a:bodyPr wrap="square" anchor="t" lIns="0" rIns="0" tIns="0" bIns="0">
-            <a:spAutoFit/>
+          <a:bodyPr wrap="square" lIns="0" rIns="0" tIns="0" bIns="0">
+            <a:noAutofit/>
           </a:bodyPr>
           <a:lstStyle/>
           <a:p>
             <a:pPr algn="l">
               <a:lnSpc>
-                <a:spcPct val="134000"/>
+                <a:spcPct val="150000"/>
               </a:lnSpc>
             </a:pPr>
             <a:r>
-              <a:rPr sz="1500" b="1" i="0">
-                <a:solidFill>
-                  <a:srgbClr val="ECEFF3"/>
-                </a:solidFill>
-                <a:latin typeface="Arial"/>
-              </a:rPr>
-              <a:t>Multimodal — and soon.  </a:t>
-            </a:r>
-            <a:r>
-              <a:rPr sz="1350" b="0" i="0">
-                <a:solidFill>
-                  <a:srgbClr val="9DA9B5"/>
-                </a:solidFill>
-                <a:latin typeface="Arial"/>
-              </a:rPr>
-              <a:t>A model on imaging alone, or </a:t>
-            </a:r>
-            <a:r>
-              <a:rPr sz="1350" b="1" i="0">
-                <a:solidFill>
-                  <a:srgbClr val="ECEFF3"/>
-                </a:solidFill>
-                <a:latin typeface="Arial"/>
-              </a:rPr>
-              <a:t>imaging plus basic clinical data</a:t>
-            </a:r>
-            <a:r>
-              <a:rPr sz="1350" b="0" i="0">
-                <a:solidFill>
-                  <a:srgbClr val="9DA9B5"/>
-                </a:solidFill>
-                <a:latin typeface="Arial"/>
-              </a:rPr>
-              <a:t>, will end in user frustration. The model a radiologist trusts pulls in </a:t>
-            </a:r>
-            <a:r>
-              <a:rPr sz="1350" b="1" i="0">
-                <a:solidFill>
-                  <a:srgbClr val="ECEFF3"/>
-                </a:solidFill>
-                <a:latin typeface="Arial"/>
-              </a:rPr>
-              <a:t>image, clinical context, risk, and history</a:t>
-            </a:r>
-            <a:r>
-              <a:rPr sz="1350" b="0" i="0">
-                <a:solidFill>
-                  <a:srgbClr val="9DA9B5"/>
-                </a:solidFill>
-                <a:latin typeface="Arial"/>
-              </a:rPr>
-              <a:t> together.</a:t>
-            </a:r>
-          </a:p>
-        </p:txBody>
-      </p:sp>
-      <p:sp>
-        <p:nvSpPr>
-          <p:cNvPr id="11" name="TextBox 10"/>
-          <p:cNvSpPr txBox="1"/>
-          <p:nvPr/>
-        </p:nvSpPr>
-        <p:spPr>
-          <a:xfrm>
-            <a:off x="777240" y="4800600"/>
-            <a:ext cx="457200" cy="822960"/>
-          </a:xfrm>
-          <a:prstGeom prst="rect">
-            <a:avLst/>
-          </a:prstGeom>
-          <a:noFill/>
-        </p:spPr>
-        <p:txBody>
-          <a:bodyPr wrap="square" anchor="t" lIns="0" rIns="0" tIns="0" bIns="0">
-            <a:spAutoFit/>
-          </a:bodyPr>
-          <a:lstStyle/>
-          <a:p>
-            <a:pPr algn="l">
-              <a:lnSpc>
-                <a:spcPct val="100000"/>
-              </a:lnSpc>
-            </a:pPr>
-            <a:r>
-              <a:rPr sz="1500" b="1" i="0">
-                <a:solidFill>
-                  <a:srgbClr val="E7AC51"/>
+              <a:rPr sz="847" b="0" i="0">
+                <a:solidFill>
+                  <a:srgbClr val="5C6975"/>
                 </a:solidFill>
                 <a:latin typeface="Consolas"/>
               </a:rPr>
-              <a:t>3</a:t>
-            </a:r>
-          </a:p>
-        </p:txBody>
-      </p:sp>
-      <p:sp>
-        <p:nvSpPr>
-          <p:cNvPr id="12" name="TextBox 11"/>
-          <p:cNvSpPr txBox="1"/>
-          <p:nvPr/>
-        </p:nvSpPr>
-        <p:spPr>
-          <a:xfrm>
-            <a:off x="1280160" y="4800600"/>
-            <a:ext cx="10104119" cy="822960"/>
-          </a:xfrm>
-          <a:prstGeom prst="rect">
-            <a:avLst/>
-          </a:prstGeom>
-          <a:noFill/>
-        </p:spPr>
-        <p:txBody>
-          <a:bodyPr wrap="square" anchor="t" lIns="0" rIns="0" tIns="0" bIns="0">
-            <a:spAutoFit/>
-          </a:bodyPr>
-          <a:lstStyle/>
-          <a:p>
-            <a:pPr algn="l">
-              <a:lnSpc>
-                <a:spcPct val="134000"/>
-              </a:lnSpc>
-            </a:pPr>
-            <a:r>
-              <a:rPr sz="1500" b="1" i="0">
-                <a:solidFill>
-                  <a:srgbClr val="ECEFF3"/>
-                </a:solidFill>
-                <a:latin typeface="Arial"/>
-              </a:rPr>
-              <a:t>The integration tax.  </a:t>
-            </a:r>
-            <a:r>
-              <a:rPr sz="1350" b="0" i="0">
-                <a:solidFill>
-                  <a:srgbClr val="9DA9B5"/>
-                </a:solidFill>
-                <a:latin typeface="Arial"/>
-              </a:rPr>
-              <a:t>A perfect model dies if it can't reach PACS. One-off integrations don't scale; onboarding happens through a platform or vendor you already run.</a:t>
-            </a:r>
-          </a:p>
-        </p:txBody>
-      </p:sp>
-      <p:sp>
-        <p:nvSpPr>
-          <p:cNvPr id="13" name="TextBox 12"/>
-          <p:cNvSpPr txBox="1"/>
-          <p:nvPr/>
-        </p:nvSpPr>
-        <p:spPr>
-          <a:xfrm>
-            <a:off x="777240" y="6172200"/>
-            <a:ext cx="10607040" cy="365760"/>
-          </a:xfrm>
-          <a:prstGeom prst="rect">
-            <a:avLst/>
-          </a:prstGeom>
-          <a:noFill/>
-        </p:spPr>
-        <p:txBody>
-          <a:bodyPr wrap="square" anchor="t" lIns="0" rIns="0" tIns="0" bIns="0">
-            <a:spAutoFit/>
-          </a:bodyPr>
-          <a:lstStyle/>
-          <a:p>
-            <a:pPr algn="l">
-              <a:lnSpc>
-                <a:spcPct val="100000"/>
-              </a:lnSpc>
-            </a:pPr>
-            <a:r>
-              <a:rPr sz="900" b="0" i="0">
-                <a:solidFill>
-                  <a:srgbClr val="5C6975"/>
-                </a:solidFill>
-                <a:latin typeface="Consolas"/>
-              </a:rPr>
-              <a:t>Sharma, BMC Cancer 2023 (275,900 mammograms) · Eisemann, Nat Med 2025 (PRAIM) · Tejani, Radiology 2024 · Allen, Mayo Clin Proc Digit Health 2024</a:t>
+              <a:t>Sharma N, et al. BMC Cancer 2023;23:460 (275,900 mammograms; multi-vendor) · Eisemann N, et al. Nat Med 2025;31:917–924 (PRAIM) · Tejani AS, et al. Radiology 2024;311:e232653 · Allen B, et al. Mayo Clin Proc Digit Health 2024;2(4)</a:t>
             </a:r>
           </a:p>
         </p:txBody>
@@ -5053,324 +4427,4 @@
   </a:objectDefaults>
   <a:extraClrSchemeLst/>
 </a:theme>
-</file>
-
-<file path=ppt/theme/theme2.xml><?xml version="1.0" encoding="utf-8"?>
-<a:theme xmlns:a="http://schemas.openxmlformats.org/drawingml/2006/main" name="Office Theme">
-  <a:themeElements>
-    <a:clrScheme name="Office">
-      <a:dk1>
-        <a:sysClr val="windowText" lastClr="000000"/>
-      </a:dk1>
-      <a:lt1>
-        <a:sysClr val="window" lastClr="FFFFFF"/>
-      </a:lt1>
-      <a:dk2>
-        <a:srgbClr val="1F497D"/>
-      </a:dk2>
-      <a:lt2>
-        <a:srgbClr val="EEECE1"/>
-      </a:lt2>
-      <a:accent1>
-        <a:srgbClr val="4F81BD"/>
-      </a:accent1>
-      <a:accent2>
-        <a:srgbClr val="C0504D"/>
-      </a:accent2>
-      <a:accent3>
-        <a:srgbClr val="9BBB59"/>
-      </a:accent3>
-      <a:accent4>
-        <a:srgbClr val="8064A2"/>
-      </a:accent4>
-      <a:accent5>
-        <a:srgbClr val="4BACC6"/>
-      </a:accent5>
-      <a:accent6>
-        <a:srgbClr val="F79646"/>
-      </a:accent6>
-      <a:hlink>
-        <a:srgbClr val="0000FF"/>
-      </a:hlink>
-      <a:folHlink>
-        <a:srgbClr val="800080"/>
-      </a:folHlink>
-    </a:clrScheme>
-    <a:fontScheme name="Office">
-      <a:majorFont>
-        <a:latin typeface="Calibri"/>
-        <a:ea typeface=""/>
-        <a:cs typeface=""/>
-        <a:font script="Jpan" typeface="ＭＳ Ｐゴシック"/>
-        <a:font script="Hang" typeface="맑은 고딕"/>
-        <a:font script="Hans" typeface="宋体"/>
-        <a:font script="Hant" typeface="新細明體"/>
-        <a:font script="Arab" typeface="Times New Roman"/>
-        <a:font script="Hebr" typeface="Times New Roman"/>
-        <a:font script="Thai" typeface="Angsana New"/>
-        <a:font script="Ethi" typeface="Nyala"/>
-        <a:font script="Beng" typeface="Vrinda"/>
-        <a:font script="Gujr" typeface="Shruti"/>
-        <a:font script="Khmr" typeface="MoolBoran"/>
-        <a:font script="Knda" typeface="Tunga"/>
-        <a:font script="Guru" typeface="Raavi"/>
-        <a:font script="Cans" typeface="Euphemia"/>
-        <a:font script="Cher" typeface="Plantagenet Cherokee"/>
-        <a:font script="Yiii" typeface="Microsoft Yi Baiti"/>
-        <a:font script="Tibt" typeface="Microsoft Himalaya"/>
-        <a:font script="Thaa" typeface="MV Boli"/>
-        <a:font script="Deva" typeface="Mangal"/>
-        <a:font script="Telu" typeface="Gautami"/>
-        <a:font script="Taml" typeface="Latha"/>
-        <a:font script="Syrc" typeface="Estrangelo Edessa"/>
-        <a:font script="Orya" typeface="Kalinga"/>
-        <a:font script="Mlym" typeface="Kartika"/>
-        <a:font script="Laoo" typeface="DokChampa"/>
-        <a:font script="Sinh" typeface="Iskoola Pota"/>
-        <a:font script="Mong" typeface="Mongolian Baiti"/>
-        <a:font script="Viet" typeface="Times New Roman"/>
-        <a:font script="Uigh" typeface="Microsoft Uighur"/>
-        <a:font script="Geor" typeface="Sylfaen"/>
-      </a:majorFont>
-      <a:minorFont>
-        <a:latin typeface="Calibri"/>
-        <a:ea typeface=""/>
-        <a:cs typeface=""/>
-        <a:font script="Jpan" typeface="ＭＳ Ｐゴシック"/>
-        <a:font script="Hang" typeface="맑은 고딕"/>
-        <a:font script="Hans" typeface="宋体"/>
-        <a:font script="Hant" typeface="新細明體"/>
-        <a:font script="Arab" typeface="Arial"/>
-        <a:font script="Hebr" typeface="Arial"/>
-        <a:font script="Thai" typeface="Cordia New"/>
-        <a:font script="Ethi" typeface="Nyala"/>
-        <a:font script="Beng" typeface="Vrinda"/>
-        <a:font script="Gujr" typeface="Shruti"/>
-        <a:font script="Khmr" typeface="DaunPenh"/>
-        <a:font script="Knda" typeface="Tunga"/>
-        <a:font script="Guru" typeface="Raavi"/>
-        <a:font script="Cans" typeface="Euphemia"/>
-        <a:font script="Cher" typeface="Plantagenet Cherokee"/>
-        <a:font script="Yiii" typeface="Microsoft Yi Baiti"/>
-        <a:font script="Tibt" typeface="Microsoft Himalaya"/>
-        <a:font script="Thaa" typeface="MV Boli"/>
-        <a:font script="Deva" typeface="Mangal"/>
-        <a:font script="Telu" typeface="Gautami"/>
-        <a:font script="Taml" typeface="Latha"/>
-        <a:font script="Syrc" typeface="Estrangelo Edessa"/>
-        <a:font script="Orya" typeface="Kalinga"/>
-        <a:font script="Mlym" typeface="Kartika"/>
-        <a:font script="Laoo" typeface="DokChampa"/>
-        <a:font script="Sinh" typeface="Iskoola Pota"/>
-        <a:font script="Mong" typeface="Mongolian Baiti"/>
-        <a:font script="Viet" typeface="Arial"/>
-        <a:font script="Uigh" typeface="Microsoft Uighur"/>
-        <a:font script="Geor" typeface="Sylfaen"/>
-      </a:minorFont>
-    </a:fontScheme>
-    <a:fmtScheme name="Office">
-      <a:fillStyleLst>
-        <a:solidFill>
-          <a:schemeClr val="phClr"/>
-        </a:solidFill>
-        <a:gradFill rotWithShape="1">
-          <a:gsLst>
-            <a:gs pos="0">
-              <a:schemeClr val="phClr">
-                <a:tint val="50000"/>
-                <a:satMod val="300000"/>
-              </a:schemeClr>
-            </a:gs>
-            <a:gs pos="35000">
-              <a:schemeClr val="phClr">
-                <a:tint val="37000"/>
-                <a:satMod val="300000"/>
-              </a:schemeClr>
-            </a:gs>
-            <a:gs pos="100000">
-              <a:schemeClr val="phClr">
-                <a:tint val="15000"/>
-                <a:satMod val="350000"/>
-              </a:schemeClr>
-            </a:gs>
-          </a:gsLst>
-          <a:lin ang="16200000" scaled="1"/>
-        </a:gradFill>
-        <a:gradFill rotWithShape="1">
-          <a:gsLst>
-            <a:gs pos="0">
-              <a:schemeClr val="phClr">
-                <a:tint val="100000"/>
-                <a:shade val="100000"/>
-                <a:satMod val="130000"/>
-              </a:schemeClr>
-            </a:gs>
-            <a:gs pos="100000">
-              <a:schemeClr val="phClr">
-                <a:tint val="50000"/>
-                <a:shade val="100000"/>
-                <a:satMod val="350000"/>
-              </a:schemeClr>
-            </a:gs>
-          </a:gsLst>
-          <a:lin ang="16200000" scaled="0"/>
-        </a:gradFill>
-      </a:fillStyleLst>
-      <a:lnStyleLst>
-        <a:ln w="9525" cap="flat" cmpd="sng" algn="ctr">
-          <a:solidFill>
-            <a:schemeClr val="phClr">
-              <a:shade val="95000"/>
-              <a:satMod val="105000"/>
-            </a:schemeClr>
-          </a:solidFill>
-          <a:prstDash val="solid"/>
-        </a:ln>
-        <a:ln w="25400" cap="flat" cmpd="sng" algn="ctr">
-          <a:solidFill>
-            <a:schemeClr val="phClr"/>
-          </a:solidFill>
-          <a:prstDash val="solid"/>
-        </a:ln>
-        <a:ln w="38100" cap="flat" cmpd="sng" algn="ctr">
-          <a:solidFill>
-            <a:schemeClr val="phClr"/>
-          </a:solidFill>
-          <a:prstDash val="solid"/>
-        </a:ln>
-      </a:lnStyleLst>
-      <a:effectStyleLst>
-        <a:effectStyle>
-          <a:effectLst>
-            <a:outerShdw blurRad="40000" dist="20000" dir="5400000" rotWithShape="0">
-              <a:srgbClr val="000000">
-                <a:alpha val="38000"/>
-              </a:srgbClr>
-            </a:outerShdw>
-          </a:effectLst>
-        </a:effectStyle>
-        <a:effectStyle>
-          <a:effectLst>
-            <a:outerShdw blurRad="40000" dist="23000" dir="5400000" rotWithShape="0">
-              <a:srgbClr val="000000">
-                <a:alpha val="35000"/>
-              </a:srgbClr>
-            </a:outerShdw>
-          </a:effectLst>
-        </a:effectStyle>
-        <a:effectStyle>
-          <a:effectLst>
-            <a:outerShdw blurRad="40000" dist="23000" dir="5400000" rotWithShape="0">
-              <a:srgbClr val="000000">
-                <a:alpha val="35000"/>
-              </a:srgbClr>
-            </a:outerShdw>
-          </a:effectLst>
-          <a:scene3d>
-            <a:camera prst="orthographicFront">
-              <a:rot lat="0" lon="0" rev="0"/>
-            </a:camera>
-            <a:lightRig rig="threePt" dir="t">
-              <a:rot lat="0" lon="0" rev="1200000"/>
-            </a:lightRig>
-          </a:scene3d>
-          <a:sp3d>
-            <a:bevelT w="63500" h="25400"/>
-          </a:sp3d>
-        </a:effectStyle>
-      </a:effectStyleLst>
-      <a:bgFillStyleLst>
-        <a:solidFill>
-          <a:schemeClr val="phClr"/>
-        </a:solidFill>
-        <a:gradFill rotWithShape="1">
-          <a:gsLst>
-            <a:gs pos="0">
-              <a:schemeClr val="phClr">
-                <a:tint val="40000"/>
-                <a:satMod val="350000"/>
-              </a:schemeClr>
-            </a:gs>
-            <a:gs pos="40000">
-              <a:schemeClr val="phClr">
-                <a:tint val="45000"/>
-                <a:shade val="99000"/>
-                <a:satMod val="350000"/>
-              </a:schemeClr>
-            </a:gs>
-            <a:gs pos="100000">
-              <a:schemeClr val="phClr">
-                <a:shade val="20000"/>
-                <a:satMod val="255000"/>
-              </a:schemeClr>
-            </a:gs>
-          </a:gsLst>
-          <a:path path="circle">
-            <a:fillToRect l="50000" t="-80000" r="50000" b="180000"/>
-          </a:path>
-        </a:gradFill>
-        <a:gradFill rotWithShape="1">
-          <a:gsLst>
-            <a:gs pos="0">
-              <a:schemeClr val="phClr">
-                <a:tint val="80000"/>
-                <a:satMod val="300000"/>
-              </a:schemeClr>
-            </a:gs>
-            <a:gs pos="100000">
-              <a:schemeClr val="phClr">
-                <a:shade val="30000"/>
-                <a:satMod val="200000"/>
-              </a:schemeClr>
-            </a:gs>
-          </a:gsLst>
-          <a:path path="circle">
-            <a:fillToRect l="50000" t="50000" r="50000" b="50000"/>
-          </a:path>
-        </a:gradFill>
-      </a:bgFillStyleLst>
-    </a:fmtScheme>
-  </a:themeElements>
-  <a:objectDefaults>
-    <a:spDef>
-      <a:spPr/>
-      <a:bodyPr/>
-      <a:lstStyle/>
-      <a:style>
-        <a:lnRef idx="1">
-          <a:schemeClr val="accent1"/>
-        </a:lnRef>
-        <a:fillRef idx="3">
-          <a:schemeClr val="accent1"/>
-        </a:fillRef>
-        <a:effectRef idx="2">
-          <a:schemeClr val="accent1"/>
-        </a:effectRef>
-        <a:fontRef idx="minor">
-          <a:schemeClr val="lt1"/>
-        </a:fontRef>
-      </a:style>
-    </a:spDef>
-    <a:lnDef>
-      <a:spPr/>
-      <a:bodyPr/>
-      <a:lstStyle/>
-      <a:style>
-        <a:lnRef idx="2">
-          <a:schemeClr val="accent1"/>
-        </a:lnRef>
-        <a:fillRef idx="0">
-          <a:schemeClr val="accent1"/>
-        </a:fillRef>
-        <a:effectRef idx="1">
-          <a:schemeClr val="accent1"/>
-        </a:effectRef>
-        <a:fontRef idx="minor">
-          <a:schemeClr val="tx1"/>
-        </a:fontRef>
-      </a:style>
-    </a:lnDef>
-  </a:objectDefaults>
-  <a:extraClrSchemeLst/>
-</a:theme>
 </file>
</xml_diff>